<commit_message>
Week 2 deck: bootstrap and shuffle slides with live figures, truth-as-surviving-rivals capstone slide; build script kept in repo
</commit_message>
<xml_diff>
--- a/slides/week-02-lecture-draft.pptx
+++ b/slides/week-02-lecture-draft.pptx
@@ -21,9 +21,12 @@
     <p:sldId id="269" r:id="rId15"/>
     <p:sldId id="270" r:id="rId16"/>
     <p:sldId id="271" r:id="rId17"/>
+    <p:sldId id="272" r:id="rId18"/>
+    <p:sldId id="273" r:id="rId19"/>
+    <p:sldId id="274" r:id="rId20"/>
   </p:sldIdLst>
   <p:notesMasterIdLst>
-    <p:notesMasterId r:id="rId18"/>
+    <p:notesMasterId r:id="rId21"/>
   </p:notesMasterIdLst>
   <p:sldSz cx="12191695" cy="6858000"/>
   <p:notesSz cx="6858000" cy="12191695"/>
@@ -1157,6 +1160,270 @@
             <a:fld id="{F7021451-1387-4CA6-816F-3879F97B5CBC}" type="slidenum">
               <a:rPr lang="en-US"/>
               <a:t>16</a:t>
+            </a:fld>
+            <a:endParaRPr lang="en-US"/>
+          </a:p>
+        </p:txBody>
+      </p:sp>
+    </p:spTree>
+    <p:extLst>
+      <p:ext uri="{BB962C8B-B14F-4D97-AF65-F5344CB8AC3E}">
+        <p14:creationId xmlns:p14="http://schemas.microsoft.com/office/powerpoint/2010/main" val="1024086991"/>
+      </p:ext>
+    </p:extLst>
+  </p:cSld>
+  <p:clrMapOvr>
+    <a:masterClrMapping/>
+  </p:clrMapOvr>
+</p:notes>
+</file>
+
+<file path=ppt/notesSlides/notesSlide17.xml><?xml version="1.0" encoding="utf-8"?>
+<p:notes xmlns:a="http://schemas.openxmlformats.org/drawingml/2006/main" xmlns:r="http://schemas.openxmlformats.org/officeDocument/2006/relationships" xmlns:p="http://schemas.openxmlformats.org/presentationml/2006/main">
+  <p:cSld>
+    <p:spTree>
+      <p:nvGrpSpPr>
+        <p:cNvPr id="1" name=""/>
+        <p:cNvGrpSpPr/>
+        <p:nvPr/>
+      </p:nvGrpSpPr>
+      <p:grpSpPr>
+        <a:xfrm>
+          <a:off x="0" y="0"/>
+          <a:ext cx="0" cy="0"/>
+          <a:chOff x="0" y="0"/>
+          <a:chExt cx="0" cy="0"/>
+        </a:xfrm>
+      </p:grpSpPr>
+      <p:sp>
+        <p:nvSpPr>
+          <p:cNvPr id="2" name="Slide Image Placeholder 1"/>
+          <p:cNvSpPr>
+            <a:spLocks noGrp="1" noRot="1" noChangeAspect="1"/>
+          </p:cNvSpPr>
+          <p:nvPr>
+            <p:ph type="sldImg"/>
+          </p:nvPr>
+        </p:nvSpPr>
+        <p:spPr/>
+      </p:sp>
+      <p:sp>
+        <p:nvSpPr>
+          <p:cNvPr id="3" name="Notes Placeholder 2"/>
+          <p:cNvSpPr>
+            <a:spLocks noGrp="1"/>
+          </p:cNvSpPr>
+          <p:nvPr>
+            <p:ph type="body" idx="1"/>
+          </p:nvPr>
+        </p:nvSpPr>
+        <p:spPr/>
+        <p:txBody>
+          <a:bodyPr/>
+          <a:lstStyle/>
+          <a:p>
+            <a:r>
+              <a:rPr lang="en-US" dirty="0"/>
+              <a:t/>
+            </a:r>
+            <a:endParaRPr lang="en-US" dirty="0"/>
+          </a:p>
+        </p:txBody>
+      </p:sp>
+      <p:sp>
+        <p:nvSpPr>
+          <p:cNvPr id="4" name="Slide Number Placeholder 3"/>
+          <p:cNvSpPr>
+            <a:spLocks noGrp="1"/>
+          </p:cNvSpPr>
+          <p:nvPr>
+            <p:ph type="sldNum" sz="quarter" idx="10"/>
+          </p:nvPr>
+        </p:nvSpPr>
+        <p:spPr/>
+        <p:txBody>
+          <a:bodyPr/>
+          <a:lstStyle/>
+          <a:p>
+            <a:fld id="{F7021451-1387-4CA6-816F-3879F97B5CBC}" type="slidenum">
+              <a:rPr lang="en-US"/>
+              <a:t>17</a:t>
+            </a:fld>
+            <a:endParaRPr lang="en-US"/>
+          </a:p>
+        </p:txBody>
+      </p:sp>
+    </p:spTree>
+    <p:extLst>
+      <p:ext uri="{BB962C8B-B14F-4D97-AF65-F5344CB8AC3E}">
+        <p14:creationId xmlns:p14="http://schemas.microsoft.com/office/powerpoint/2010/main" val="1024086991"/>
+      </p:ext>
+    </p:extLst>
+  </p:cSld>
+  <p:clrMapOvr>
+    <a:masterClrMapping/>
+  </p:clrMapOvr>
+</p:notes>
+</file>
+
+<file path=ppt/notesSlides/notesSlide18.xml><?xml version="1.0" encoding="utf-8"?>
+<p:notes xmlns:a="http://schemas.openxmlformats.org/drawingml/2006/main" xmlns:r="http://schemas.openxmlformats.org/officeDocument/2006/relationships" xmlns:p="http://schemas.openxmlformats.org/presentationml/2006/main">
+  <p:cSld>
+    <p:spTree>
+      <p:nvGrpSpPr>
+        <p:cNvPr id="1" name=""/>
+        <p:cNvGrpSpPr/>
+        <p:nvPr/>
+      </p:nvGrpSpPr>
+      <p:grpSpPr>
+        <a:xfrm>
+          <a:off x="0" y="0"/>
+          <a:ext cx="0" cy="0"/>
+          <a:chOff x="0" y="0"/>
+          <a:chExt cx="0" cy="0"/>
+        </a:xfrm>
+      </p:grpSpPr>
+      <p:sp>
+        <p:nvSpPr>
+          <p:cNvPr id="2" name="Slide Image Placeholder 1"/>
+          <p:cNvSpPr>
+            <a:spLocks noGrp="1" noRot="1" noChangeAspect="1"/>
+          </p:cNvSpPr>
+          <p:nvPr>
+            <p:ph type="sldImg"/>
+          </p:nvPr>
+        </p:nvSpPr>
+        <p:spPr/>
+      </p:sp>
+      <p:sp>
+        <p:nvSpPr>
+          <p:cNvPr id="3" name="Notes Placeholder 2"/>
+          <p:cNvSpPr>
+            <a:spLocks noGrp="1"/>
+          </p:cNvSpPr>
+          <p:nvPr>
+            <p:ph type="body" idx="1"/>
+          </p:nvPr>
+        </p:nvSpPr>
+        <p:spPr/>
+        <p:txBody>
+          <a:bodyPr/>
+          <a:lstStyle/>
+          <a:p>
+            <a:r>
+              <a:rPr lang="en-US" dirty="0"/>
+              <a:t/>
+            </a:r>
+            <a:endParaRPr lang="en-US" dirty="0"/>
+          </a:p>
+        </p:txBody>
+      </p:sp>
+      <p:sp>
+        <p:nvSpPr>
+          <p:cNvPr id="4" name="Slide Number Placeholder 3"/>
+          <p:cNvSpPr>
+            <a:spLocks noGrp="1"/>
+          </p:cNvSpPr>
+          <p:nvPr>
+            <p:ph type="sldNum" sz="quarter" idx="10"/>
+          </p:nvPr>
+        </p:nvSpPr>
+        <p:spPr/>
+        <p:txBody>
+          <a:bodyPr/>
+          <a:lstStyle/>
+          <a:p>
+            <a:fld id="{F7021451-1387-4CA6-816F-3879F97B5CBC}" type="slidenum">
+              <a:rPr lang="en-US"/>
+              <a:t>18</a:t>
+            </a:fld>
+            <a:endParaRPr lang="en-US"/>
+          </a:p>
+        </p:txBody>
+      </p:sp>
+    </p:spTree>
+    <p:extLst>
+      <p:ext uri="{BB962C8B-B14F-4D97-AF65-F5344CB8AC3E}">
+        <p14:creationId xmlns:p14="http://schemas.microsoft.com/office/powerpoint/2010/main" val="1024086991"/>
+      </p:ext>
+    </p:extLst>
+  </p:cSld>
+  <p:clrMapOvr>
+    <a:masterClrMapping/>
+  </p:clrMapOvr>
+</p:notes>
+</file>
+
+<file path=ppt/notesSlides/notesSlide19.xml><?xml version="1.0" encoding="utf-8"?>
+<p:notes xmlns:a="http://schemas.openxmlformats.org/drawingml/2006/main" xmlns:r="http://schemas.openxmlformats.org/officeDocument/2006/relationships" xmlns:p="http://schemas.openxmlformats.org/presentationml/2006/main">
+  <p:cSld>
+    <p:spTree>
+      <p:nvGrpSpPr>
+        <p:cNvPr id="1" name=""/>
+        <p:cNvGrpSpPr/>
+        <p:nvPr/>
+      </p:nvGrpSpPr>
+      <p:grpSpPr>
+        <a:xfrm>
+          <a:off x="0" y="0"/>
+          <a:ext cx="0" cy="0"/>
+          <a:chOff x="0" y="0"/>
+          <a:chExt cx="0" cy="0"/>
+        </a:xfrm>
+      </p:grpSpPr>
+      <p:sp>
+        <p:nvSpPr>
+          <p:cNvPr id="2" name="Slide Image Placeholder 1"/>
+          <p:cNvSpPr>
+            <a:spLocks noGrp="1" noRot="1" noChangeAspect="1"/>
+          </p:cNvSpPr>
+          <p:nvPr>
+            <p:ph type="sldImg"/>
+          </p:nvPr>
+        </p:nvSpPr>
+        <p:spPr/>
+      </p:sp>
+      <p:sp>
+        <p:nvSpPr>
+          <p:cNvPr id="3" name="Notes Placeholder 2"/>
+          <p:cNvSpPr>
+            <a:spLocks noGrp="1"/>
+          </p:cNvSpPr>
+          <p:nvPr>
+            <p:ph type="body" idx="1"/>
+          </p:nvPr>
+        </p:nvSpPr>
+        <p:spPr/>
+        <p:txBody>
+          <a:bodyPr/>
+          <a:lstStyle/>
+          <a:p>
+            <a:r>
+              <a:rPr lang="en-US" dirty="0"/>
+              <a:t/>
+            </a:r>
+            <a:endParaRPr lang="en-US" dirty="0"/>
+          </a:p>
+        </p:txBody>
+      </p:sp>
+      <p:sp>
+        <p:nvSpPr>
+          <p:cNvPr id="4" name="Slide Number Placeholder 3"/>
+          <p:cNvSpPr>
+            <a:spLocks noGrp="1"/>
+          </p:cNvSpPr>
+          <p:nvPr>
+            <p:ph type="sldNum" sz="quarter" idx="10"/>
+          </p:nvPr>
+        </p:nvSpPr>
+        <p:spPr/>
+        <p:txBody>
+          <a:bodyPr/>
+          <a:lstStyle/>
+          <a:p>
+            <a:fld id="{F7021451-1387-4CA6-816F-3879F97B5CBC}" type="slidenum">
+              <a:rPr lang="en-US"/>
+              <a:t>19</a:t>
             </a:fld>
             <a:endParaRPr lang="en-US"/>
           </a:p>
@@ -3149,7 +3416,7 @@
                 <a:ea typeface="Calibri" pitchFamily="34" charset="-122"/>
                 <a:cs typeface="Calibri" pitchFamily="34" charset="-120"/>
               </a:rPr>
-              <a:t>YOUR HANDS, ON THE TOOLS</a:t>
+              <a:t>QUESTION 2, DRAWN</a:t>
             </a:r>
             <a:endParaRPr lang="en-US" sz="1300" dirty="0"/>
           </a:p>
@@ -3188,7 +3455,7 @@
                 <a:ea typeface="Cambria" pitchFamily="34" charset="-122"/>
                 <a:cs typeface="Cambria" pitchFamily="34" charset="-120"/>
               </a:rPr>
-              <a:t>The shuffle test, five moves (and a z-score first)</a:t>
+              <a:t>The shuffle test: could chance deal this gap?</a:t>
             </a:r>
             <a:endParaRPr lang="en-US" sz="3400" dirty="0"/>
           </a:p>
@@ -3203,7 +3470,7 @@
         <p:spPr>
           <a:xfrm>
             <a:off x="640080" y="2011680"/>
-            <a:ext cx="6035040" cy="4206240"/>
+            <a:ext cx="4937760" cy="4206240"/>
           </a:xfrm>
           <a:prstGeom prst="rect">
             <a:avLst/>
@@ -3234,7 +3501,7 @@
                 <a:ea typeface="Calibri" pitchFamily="34" charset="-122"/>
                 <a:cs typeface="Calibri" pitchFamily="34" charset="-120"/>
               </a:rPr>
-              <a:t>Warm-up, the z-score: (value − mean) / std. “Is 3 nevers a lot?” z = +5.7 says yes, loudly. The notebook has a YOUR TURN with your own word.</a:t>
+              <a:t>The real gap: “water” appears 2.7 more times per 1,000 words in r/gardening than r/buildapc.</a:t>
             </a:r>
             <a:endParaRPr lang="en-US" sz="1500" dirty="0"/>
           </a:p>
@@ -3258,7 +3525,7 @@
                 <a:ea typeface="Calibri" pitchFamily="34" charset="-122"/>
                 <a:cs typeface="Calibri" pitchFamily="34" charset="-120"/>
               </a:rPr>
-              <a:t>1. Pick a word and two communities.  2. WRITE the prediction first.  3. Run the shuffles.  4. Read the effect size.  5. Say the sentence.</a:t>
+              <a:t>Shuffle the community labels 1,000 times, recount each time: the gray pile is what chance can do.</a:t>
             </a:r>
             <a:endParaRPr lang="en-US" sz="1500" dirty="0"/>
           </a:p>
@@ -3282,307 +3549,59 @@
                 <a:ea typeface="Calibri" pitchFamily="34" charset="-122"/>
                 <a:cs typeface="Calibri" pitchFamily="34" charset="-120"/>
               </a:rPr>
-              <a:t>The sentence: “X appears N more times per 1,000 words in r/Y (p = Z), which is / is not beyond chance, and is / is not big enough to matter.”</a:t>
+              <a:t>The real gap stands far outside the pile. Empirical p ≈ 0: this elevation is not luck.</a:t>
             </a:r>
             <a:endParaRPr lang="en-US" sz="1500" dirty="0"/>
           </a:p>
-        </p:txBody>
-      </p:sp>
-      <p:sp>
-        <p:nvSpPr>
-          <p:cNvPr id="5" name="Shape 3"/>
-          <p:cNvSpPr/>
-          <p:nvPr/>
-        </p:nvSpPr>
-        <p:spPr>
-          <a:xfrm>
-            <a:off x="7040880" y="2011680"/>
-            <a:ext cx="4480560" cy="3657600"/>
-          </a:xfrm>
-          <a:prstGeom prst="roundRect">
-            <a:avLst>
-              <a:gd name="adj" fmla="val 2500"/>
-            </a:avLst>
-          </a:prstGeom>
-          <a:solidFill>
-            <a:srgbClr val="F4EEE8"/>
-          </a:solidFill>
-          <a:ln/>
-        </p:spPr>
-      </p:sp>
-      <p:sp>
-        <p:nvSpPr>
-          <p:cNvPr id="6" name="Text 4"/>
-          <p:cNvSpPr/>
-          <p:nvPr/>
-        </p:nvSpPr>
-        <p:spPr>
-          <a:xfrm>
-            <a:off x="7315200" y="2240280"/>
-            <a:ext cx="3931920" cy="320040"/>
-          </a:xfrm>
-          <a:prstGeom prst="rect">
-            <a:avLst/>
-          </a:prstGeom>
-          <a:noFill/>
-          <a:ln/>
-        </p:spPr>
-        <p:txBody>
-          <a:bodyPr wrap="square" rtlCol="0" anchor="ctr"/>
-          <a:lstStyle/>
-          <a:p>
-            <a:pPr indent="0" marL="0">
-              <a:buNone/>
-            </a:pPr>
-            <a:r>
-              <a:rPr lang="en-US" sz="1200" b="1" spc="200" kern="0" dirty="0">
-                <a:solidFill>
-                  <a:srgbClr val="6B6B63"/>
+          <a:p>
+            <a:pPr marL="152400" indent="-152400">
+              <a:lnSpc>
+                <a:spcPct val="115000"/>
+              </a:lnSpc>
+              <a:spcAft>
+                <a:spcPts val="1000"/>
+              </a:spcAft>
+              <a:buSzPct val="100000"/>
+              <a:buChar char="•"/>
+            </a:pPr>
+            <a:r>
+              <a:rPr lang="en-US" sz="1500" dirty="0">
+                <a:solidFill>
+                  <a:srgbClr val="1A1A1A"/>
                 </a:solidFill>
                 <a:latin typeface="Calibri" pitchFamily="34" charset="0"/>
                 <a:ea typeface="Calibri" pitchFamily="34" charset="-122"/>
                 <a:cs typeface="Calibri" pitchFamily="34" charset="-120"/>
               </a:rPr>
-              <a:t>the traps, named</a:t>
-            </a:r>
-            <a:endParaRPr lang="en-US" sz="1200" dirty="0"/>
-          </a:p>
-        </p:txBody>
-      </p:sp>
-      <p:sp>
-        <p:nvSpPr>
-          <p:cNvPr id="7" name="Text 5"/>
-          <p:cNvSpPr/>
-          <p:nvPr/>
-        </p:nvSpPr>
-        <p:spPr>
-          <a:xfrm>
-            <a:off x="7315200" y="2743200"/>
-            <a:ext cx="3931920" cy="320040"/>
-          </a:xfrm>
-          <a:prstGeom prst="rect">
-            <a:avLst/>
-          </a:prstGeom>
-          <a:noFill/>
-          <a:ln/>
-        </p:spPr>
-        <p:txBody>
-          <a:bodyPr wrap="square" lIns="0" tIns="0" rIns="0" bIns="0" rtlCol="0" anchor="ctr"/>
-          <a:lstStyle/>
-          <a:p>
-            <a:pPr indent="0" marL="0">
-              <a:buNone/>
-            </a:pPr>
-            <a:r>
-              <a:rPr lang="en-US" sz="1400" b="1" dirty="0">
-                <a:solidFill>
-                  <a:srgbClr val="7A3B2E"/>
-                </a:solidFill>
-                <a:latin typeface="Calibri" pitchFamily="34" charset="0"/>
-                <a:ea typeface="Calibri" pitchFamily="34" charset="-122"/>
-                <a:cs typeface="Calibri" pitchFamily="34" charset="-120"/>
-              </a:rPr>
-              <a:t>selection</a:t>
-            </a:r>
-            <a:endParaRPr lang="en-US" sz="1400" dirty="0"/>
-          </a:p>
-        </p:txBody>
-      </p:sp>
-      <p:sp>
-        <p:nvSpPr>
-          <p:cNvPr id="8" name="Text 6"/>
-          <p:cNvSpPr/>
-          <p:nvPr/>
-        </p:nvSpPr>
-        <p:spPr>
-          <a:xfrm>
-            <a:off x="7315200" y="3063240"/>
-            <a:ext cx="3931920" cy="548640"/>
-          </a:xfrm>
-          <a:prstGeom prst="rect">
-            <a:avLst/>
-          </a:prstGeom>
-          <a:noFill/>
-          <a:ln/>
-        </p:spPr>
-        <p:txBody>
-          <a:bodyPr wrap="square" lIns="0" tIns="0" rIns="0" bIns="0" rtlCol="0" anchor="t"/>
-          <a:lstStyle/>
-          <a:p>
-            <a:pPr indent="0" marL="0">
-              <a:buNone/>
-            </a:pPr>
-            <a:r>
-              <a:rPr lang="en-US" sz="1200" dirty="0">
-                <a:solidFill>
-                  <a:srgbClr val="1A1A1A"/>
-                </a:solidFill>
-                <a:latin typeface="Calibri" pitchFamily="34" charset="0"/>
-                <a:ea typeface="Calibri" pitchFamily="34" charset="-122"/>
-                <a:cs typeface="Calibri" pitchFamily="34" charset="-120"/>
-              </a:rPr>
-              <a:t>testing the word you chose FOR its extremity</a:t>
-            </a:r>
-            <a:endParaRPr lang="en-US" sz="1200" dirty="0"/>
-          </a:p>
-        </p:txBody>
-      </p:sp>
-      <p:sp>
-        <p:nvSpPr>
-          <p:cNvPr id="9" name="Text 7"/>
-          <p:cNvSpPr/>
-          <p:nvPr/>
-        </p:nvSpPr>
-        <p:spPr>
-          <a:xfrm>
-            <a:off x="7315200" y="3703320"/>
-            <a:ext cx="3931920" cy="320040"/>
-          </a:xfrm>
-          <a:prstGeom prst="rect">
-            <a:avLst/>
-          </a:prstGeom>
-          <a:noFill/>
-          <a:ln/>
-        </p:spPr>
-        <p:txBody>
-          <a:bodyPr wrap="square" lIns="0" tIns="0" rIns="0" bIns="0" rtlCol="0" anchor="ctr"/>
-          <a:lstStyle/>
-          <a:p>
-            <a:pPr indent="0" marL="0">
-              <a:buNone/>
-            </a:pPr>
-            <a:r>
-              <a:rPr lang="en-US" sz="1400" b="1" dirty="0">
-                <a:solidFill>
-                  <a:srgbClr val="B9852F"/>
-                </a:solidFill>
-                <a:latin typeface="Calibri" pitchFamily="34" charset="0"/>
-                <a:ea typeface="Calibri" pitchFamily="34" charset="-122"/>
-                <a:cs typeface="Calibri" pitchFamily="34" charset="-120"/>
-              </a:rPr>
-              <a:t>multiplicity</a:t>
-            </a:r>
-            <a:endParaRPr lang="en-US" sz="1400" dirty="0"/>
-          </a:p>
-        </p:txBody>
-      </p:sp>
-      <p:sp>
-        <p:nvSpPr>
-          <p:cNvPr id="10" name="Text 8"/>
-          <p:cNvSpPr/>
-          <p:nvPr/>
-        </p:nvSpPr>
-        <p:spPr>
-          <a:xfrm>
-            <a:off x="7315200" y="4023360"/>
-            <a:ext cx="3931920" cy="548640"/>
-          </a:xfrm>
-          <a:prstGeom prst="rect">
-            <a:avLst/>
-          </a:prstGeom>
-          <a:noFill/>
-          <a:ln/>
-        </p:spPr>
-        <p:txBody>
-          <a:bodyPr wrap="square" lIns="0" tIns="0" rIns="0" bIns="0" rtlCol="0" anchor="t"/>
-          <a:lstStyle/>
-          <a:p>
-            <a:pPr indent="0" marL="0">
-              <a:buNone/>
-            </a:pPr>
-            <a:r>
-              <a:rPr lang="en-US" sz="1200" dirty="0">
-                <a:solidFill>
-                  <a:srgbClr val="1A1A1A"/>
-                </a:solidFill>
-                <a:latin typeface="Calibri" pitchFamily="34" charset="0"/>
-                <a:ea typeface="Calibri" pitchFamily="34" charset="-122"/>
-                <a:cs typeface="Calibri" pitchFamily="34" charset="-120"/>
-              </a:rPr>
-              <a:t>1,500 words at p&lt;.05: ~75 pass by luck</a:t>
-            </a:r>
-            <a:endParaRPr lang="en-US" sz="1200" dirty="0"/>
-          </a:p>
-        </p:txBody>
-      </p:sp>
-      <p:sp>
-        <p:nvSpPr>
-          <p:cNvPr id="11" name="Text 9"/>
-          <p:cNvSpPr/>
-          <p:nvPr/>
-        </p:nvSpPr>
-        <p:spPr>
-          <a:xfrm>
-            <a:off x="7315200" y="4663440"/>
-            <a:ext cx="3931920" cy="320040"/>
-          </a:xfrm>
-          <a:prstGeom prst="rect">
-            <a:avLst/>
-          </a:prstGeom>
-          <a:noFill/>
-          <a:ln/>
-        </p:spPr>
-        <p:txBody>
-          <a:bodyPr wrap="square" lIns="0" tIns="0" rIns="0" bIns="0" rtlCol="0" anchor="ctr"/>
-          <a:lstStyle/>
-          <a:p>
-            <a:pPr indent="0" marL="0">
-              <a:buNone/>
-            </a:pPr>
-            <a:r>
-              <a:rPr lang="en-US" sz="1400" b="1" dirty="0">
-                <a:solidFill>
-                  <a:srgbClr val="2E5F8A"/>
-                </a:solidFill>
-                <a:latin typeface="Calibri" pitchFamily="34" charset="0"/>
-                <a:ea typeface="Calibri" pitchFamily="34" charset="-122"/>
-                <a:cs typeface="Calibri" pitchFamily="34" charset="-120"/>
-              </a:rPr>
-              <a:t>size</a:t>
-            </a:r>
-            <a:endParaRPr lang="en-US" sz="1400" dirty="0"/>
-          </a:p>
-        </p:txBody>
-      </p:sp>
-      <p:sp>
-        <p:nvSpPr>
-          <p:cNvPr id="12" name="Text 10"/>
-          <p:cNvSpPr/>
-          <p:nvPr/>
-        </p:nvSpPr>
-        <p:spPr>
-          <a:xfrm>
-            <a:off x="7315200" y="4983480"/>
-            <a:ext cx="3931920" cy="548640"/>
-          </a:xfrm>
-          <a:prstGeom prst="rect">
-            <a:avLst/>
-          </a:prstGeom>
-          <a:noFill/>
-          <a:ln/>
-        </p:spPr>
-        <p:txBody>
-          <a:bodyPr wrap="square" lIns="0" tIns="0" rIns="0" bIns="0" rtlCol="0" anchor="t"/>
-          <a:lstStyle/>
-          <a:p>
-            <a:pPr indent="0" marL="0">
-              <a:buNone/>
-            </a:pPr>
-            <a:r>
-              <a:rPr lang="en-US" sz="1200" dirty="0">
-                <a:solidFill>
-                  <a:srgbClr val="1A1A1A"/>
-                </a:solidFill>
-                <a:latin typeface="Calibri" pitchFamily="34" charset="0"/>
-                <a:ea typeface="Calibri" pitchFamily="34" charset="-122"/>
-                <a:cs typeface="Calibri" pitchFamily="34" charset="-120"/>
-              </a:rPr>
-              <a:t>with enough data, microscopic gaps pass</a:t>
-            </a:r>
-            <a:endParaRPr lang="en-US" sz="1200" dirty="0"/>
-          </a:p>
-        </p:txBody>
-      </p:sp>
+              <a:t>Five moves, in the notebook with YOUR-TURN blanks: pick, predict, shuffle, read the effect, say the sentence.</a:t>
+            </a:r>
+            <a:endParaRPr lang="en-US" sz="1500" dirty="0"/>
+          </a:p>
+        </p:txBody>
+      </p:sp>
+      <p:pic>
+        <p:nvPicPr>
+          <p:cNvPr id="5" name="Image 0" descr="/tmp/figs/shuffle.png">    </p:cNvPr>
+          <p:cNvPicPr>
+            <a:picLocks noChangeAspect="1"/>
+          </p:cNvPicPr>
+          <p:nvPr/>
+        </p:nvPicPr>
+        <p:blipFill>
+          <a:blip r:embed="rId1"/>
+          <a:srcRect l="0" r="0" t="0" b="0"/>
+          <a:stretch/>
+        </p:blipFill>
+        <p:spPr>
+          <a:xfrm>
+            <a:off x="5852160" y="1920240"/>
+            <a:ext cx="5669280" cy="3931920"/>
+          </a:xfrm>
+          <a:prstGeom prst="rect">
+            <a:avLst/>
+          </a:prstGeom>
+        </p:spPr>
+      </p:pic>
     </p:spTree>
   </p:cSld>
   <p:clrMapOvr>
@@ -3642,13 +3661,13 @@
             <a:r>
               <a:rPr lang="en-US" sz="1300" b="1" spc="300" kern="0" dirty="0">
                 <a:solidFill>
-                  <a:srgbClr val="7A3B2E"/>
+                  <a:srgbClr val="2E5F8A"/>
                 </a:solidFill>
                 <a:latin typeface="Calibri" pitchFamily="34" charset="0"/>
                 <a:ea typeface="Calibri" pitchFamily="34" charset="-122"/>
                 <a:cs typeface="Calibri" pitchFamily="34" charset="-120"/>
               </a:rPr>
-              <a:t>THE REPLICATION · YOURS</a:t>
+              <a:t>QUESTION 3, DRAWN</a:t>
             </a:r>
             <a:endParaRPr lang="en-US" sz="1300" dirty="0"/>
           </a:p>
@@ -3687,7 +3706,7 @@
                 <a:ea typeface="Cambria" pitchFamily="34" charset="-122"/>
                 <a:cs typeface="Cambria" pitchFamily="34" charset="-120"/>
               </a:rPr>
-              <a:t>Bollen on Reddit: hold the community fixed</a:t>
+              <a:t>The bootstrap: how big, give or take?</a:t>
             </a:r>
             <a:endParaRPr lang="en-US" sz="3400" dirty="0"/>
           </a:p>
@@ -3733,7 +3752,7 @@
                 <a:ea typeface="Calibri" pitchFamily="34" charset="-122"/>
                 <a:cs typeface="Calibri" pitchFamily="34" charset="-120"/>
               </a:rPr>
-              <a:t>Schmidt's demand, satisfied: one subreddit, fifteen years, only the year varies. Composition cannot write this trend.</a:t>
+              <a:t>The shuffle asked “could it be zero?” The bootstrap asks the other question: “what sizes are believable?”</a:t>
             </a:r>
             <a:endParaRPr lang="en-US" sz="1500" dirty="0"/>
           </a:p>
@@ -3757,7 +3776,7 @@
                 <a:ea typeface="Calibri" pitchFamily="34" charset="-122"/>
                 <a:cs typeface="Calibri" pitchFamily="34" charset="-120"/>
               </a:rPr>
-              <a:t>The honest adaptation: the paper's phrases are too rare for our samples, so we count the absolutist index (always, never, nothing...), 19 words that track distress language (Al-Mosaiwi &amp; Johnstone 2018).</a:t>
+              <a:t>Resample your own comments WITH replacement, 1,000 times; recompute the gap each time. Your data votes on its own uncertainty.</a:t>
             </a:r>
             <a:endParaRPr lang="en-US" sz="1500" dirty="0"/>
           </a:p>
@@ -3781,7 +3800,7 @@
                 <a:ea typeface="Calibri" pitchFamily="34" charset="-122"/>
                 <a:cs typeface="Calibri" pitchFamily="34" charset="-120"/>
               </a:rPr>
-              <a:t>The room's protocol: predict the shape out loud → run the default together → each pair swaps in a community they know → bring the plot back.</a:t>
+              <a:t>The middle 95% is the confidence interval: here, 1.4 to 4.1 per 1,000. Far from zero (a finding), wide (stay humble about the exact number).</a:t>
             </a:r>
             <a:endParaRPr lang="en-US" sz="1500" dirty="0"/>
           </a:p>
@@ -3805,185 +3824,35 @@
                 <a:ea typeface="Calibri" pitchFamily="34" charset="-122"/>
                 <a:cs typeface="Calibri" pitchFamily="34" charset="-120"/>
               </a:rPr>
-              <a:t>Ten plots from ten communities is a real replication study, made in one classroom.</a:t>
+              <a:t>The error bars on today's replication plot are exactly this, one bootstrap per year.</a:t>
             </a:r>
             <a:endParaRPr lang="en-US" sz="1500" dirty="0"/>
           </a:p>
         </p:txBody>
       </p:sp>
-      <p:sp>
-        <p:nvSpPr>
-          <p:cNvPr id="5" name="Shape 3"/>
-          <p:cNvSpPr/>
-          <p:nvPr/>
-        </p:nvSpPr>
-        <p:spPr>
-          <a:xfrm>
-            <a:off x="5852160" y="2011680"/>
-            <a:ext cx="5669280" cy="3657600"/>
-          </a:xfrm>
-          <a:prstGeom prst="roundRect">
-            <a:avLst>
-              <a:gd name="adj" fmla="val 2500"/>
-            </a:avLst>
-          </a:prstGeom>
-          <a:solidFill>
-            <a:srgbClr val="F4EEE8"/>
-          </a:solidFill>
-          <a:ln/>
-        </p:spPr>
-      </p:sp>
-      <p:sp>
-        <p:nvSpPr>
-          <p:cNvPr id="6" name="Text 4"/>
-          <p:cNvSpPr/>
-          <p:nvPr/>
-        </p:nvSpPr>
-        <p:spPr>
-          <a:xfrm>
-            <a:off x="6126480" y="2286000"/>
-            <a:ext cx="5120640" cy="320040"/>
-          </a:xfrm>
-          <a:prstGeom prst="rect">
-            <a:avLst/>
-          </a:prstGeom>
-          <a:noFill/>
-          <a:ln/>
-        </p:spPr>
-        <p:txBody>
-          <a:bodyPr wrap="square" rtlCol="0" anchor="ctr"/>
-          <a:lstStyle/>
-          <a:p>
-            <a:pPr indent="0" marL="0">
-              <a:buNone/>
-            </a:pPr>
-            <a:r>
-              <a:rPr lang="en-US" sz="1200" b="1" spc="200" kern="0" dirty="0">
-                <a:solidFill>
-                  <a:srgbClr val="6B6B63"/>
-                </a:solidFill>
-                <a:latin typeface="Calibri" pitchFamily="34" charset="0"/>
-                <a:ea typeface="Calibri" pitchFamily="34" charset="-122"/>
-                <a:cs typeface="Calibri" pitchFamily="34" charset="-120"/>
-              </a:rPr>
-              <a:t>the design, in one line</a:t>
-            </a:r>
-            <a:endParaRPr lang="en-US" sz="1200" dirty="0"/>
-          </a:p>
-        </p:txBody>
-      </p:sp>
-      <p:sp>
-        <p:nvSpPr>
-          <p:cNvPr id="7" name="Text 5"/>
-          <p:cNvSpPr/>
-          <p:nvPr/>
-        </p:nvSpPr>
-        <p:spPr>
-          <a:xfrm>
-            <a:off x="6126480" y="2743200"/>
-            <a:ext cx="5120640" cy="1097280"/>
-          </a:xfrm>
-          <a:prstGeom prst="rect">
-            <a:avLst/>
-          </a:prstGeom>
-          <a:noFill/>
-          <a:ln/>
-        </p:spPr>
-        <p:txBody>
-          <a:bodyPr wrap="square" lIns="0" tIns="0" rIns="0" bIns="0" rtlCol="0" anchor="ctr"/>
-          <a:lstStyle/>
-          <a:p>
-            <a:pPr indent="0" marL="0">
-              <a:buNone/>
-            </a:pPr>
-            <a:r>
-              <a:rPr lang="en-US" sz="1500" dirty="0">
-                <a:solidFill>
-                  <a:srgbClr val="1A1A1A"/>
-                </a:solidFill>
-                <a:latin typeface="Courier New" pitchFamily="34" charset="0"/>
-                <a:ea typeface="Courier New" pitchFamily="34" charset="-122"/>
-                <a:cs typeface="Courier New" pitchFamily="34" charset="-120"/>
-              </a:rPr>
-              <a:t>rate(absolutist words | r/AskReddit, year)</a:t>
-            </a:r>
-            <a:endParaRPr lang="en-US" sz="1500" dirty="0"/>
-          </a:p>
-          <a:p>
-            <a:pPr indent="0" marL="0">
-              <a:buNone/>
-            </a:pPr>
-            <a:r>
-              <a:rPr lang="en-US" sz="1500" dirty="0">
-                <a:solidFill>
-                  <a:srgbClr val="1A1A1A"/>
-                </a:solidFill>
-                <a:latin typeface="Courier New" pitchFamily="34" charset="0"/>
-                <a:ea typeface="Courier New" pitchFamily="34" charset="-122"/>
-                <a:cs typeface="Courier New" pitchFamily="34" charset="-120"/>
-              </a:rPr>
-              <a:t>for year in 2010 … 2024</a:t>
-            </a:r>
-            <a:endParaRPr lang="en-US" sz="1500" dirty="0"/>
-          </a:p>
-        </p:txBody>
-      </p:sp>
-      <p:sp>
-        <p:nvSpPr>
-          <p:cNvPr id="8" name="Text 6"/>
-          <p:cNvSpPr/>
-          <p:nvPr/>
-        </p:nvSpPr>
-        <p:spPr>
-          <a:xfrm>
-            <a:off x="6126480" y="4023360"/>
-            <a:ext cx="5120640" cy="1280160"/>
-          </a:xfrm>
-          <a:prstGeom prst="rect">
-            <a:avLst/>
-          </a:prstGeom>
-          <a:noFill/>
-          <a:ln/>
-        </p:spPr>
-        <p:txBody>
-          <a:bodyPr wrap="square" lIns="0" tIns="0" rIns="0" bIns="0" rtlCol="0" anchor="ctr"/>
-          <a:lstStyle/>
-          <a:p>
-            <a:pPr indent="0" marL="0">
-              <a:buNone/>
-            </a:pPr>
-            <a:r>
-              <a:rPr lang="en-US" sz="1400" i="1" dirty="0">
-                <a:solidFill>
-                  <a:srgbClr val="1A1A1A"/>
-                </a:solidFill>
-                <a:latin typeface="Calibri" pitchFamily="34" charset="0"/>
-                <a:ea typeface="Calibri" pitchFamily="34" charset="-122"/>
-                <a:cs typeface="Calibri" pitchFamily="34" charset="-120"/>
-              </a:rPr>
-              <a:t>…then the trend itself goes on trial:</a:t>
-            </a:r>
-            <a:endParaRPr lang="en-US" sz="1400" dirty="0"/>
-          </a:p>
-          <a:p>
-            <a:pPr indent="0" marL="0">
-              <a:buNone/>
-            </a:pPr>
-            <a:r>
-              <a:rPr lang="en-US" sz="1400" i="1" dirty="0">
-                <a:solidFill>
-                  <a:srgbClr val="1A1A1A"/>
-                </a:solidFill>
-                <a:latin typeface="Calibri" pitchFamily="34" charset="0"/>
-                <a:ea typeface="Calibri" pitchFamily="34" charset="-122"/>
-                <a:cs typeface="Calibri" pitchFamily="34" charset="-120"/>
-              </a:rPr>
-              <a:t>correlate with year, and shuffle the years 1,000 times.</a:t>
-            </a:r>
-            <a:endParaRPr lang="en-US" sz="1400" dirty="0"/>
-          </a:p>
-        </p:txBody>
-      </p:sp>
+      <p:pic>
+        <p:nvPicPr>
+          <p:cNvPr id="5" name="Image 0" descr="/tmp/figs/bootstrap.png">    </p:cNvPr>
+          <p:cNvPicPr>
+            <a:picLocks noChangeAspect="1"/>
+          </p:cNvPicPr>
+          <p:nvPr/>
+        </p:nvPicPr>
+        <p:blipFill>
+          <a:blip r:embed="rId1"/>
+          <a:srcRect l="0" r="0" t="0" b="0"/>
+          <a:stretch/>
+        </p:blipFill>
+        <p:spPr>
+          <a:xfrm>
+            <a:off x="5852160" y="1920240"/>
+            <a:ext cx="5669280" cy="3931920"/>
+          </a:xfrm>
+          <a:prstGeom prst="rect">
+            <a:avLst/>
+          </a:prstGeom>
+        </p:spPr>
+      </p:pic>
     </p:spTree>
   </p:cSld>
   <p:clrMapOvr>
@@ -4043,13 +3912,13 @@
             <a:r>
               <a:rPr lang="en-US" sz="1300" b="1" spc="300" kern="0" dirty="0">
                 <a:solidFill>
-                  <a:srgbClr val="B9852F"/>
+                  <a:srgbClr val="7A3B2E"/>
                 </a:solidFill>
                 <a:latin typeface="Calibri" pitchFamily="34" charset="0"/>
                 <a:ea typeface="Calibri" pitchFamily="34" charset="-122"/>
                 <a:cs typeface="Calibri" pitchFamily="34" charset="-120"/>
               </a:rPr>
-              <a:t>THE REPLICATION · A SAMPLE RUN</a:t>
+              <a:t>THE TRAPS, NAMED</a:t>
             </a:r>
             <a:endParaRPr lang="en-US" sz="1300" dirty="0"/>
           </a:p>
@@ -4088,68 +3957,99 @@
                 <a:ea typeface="Cambria" pitchFamily="34" charset="-122"/>
                 <a:cs typeface="Cambria" pitchFamily="34" charset="-120"/>
               </a:rPr>
-              <a:t>It climbs here too, with composition controlled</a:t>
+              <a:t>Three ways significance fools you</a:t>
             </a:r>
             <a:endParaRPr lang="en-US" sz="3400" dirty="0"/>
           </a:p>
         </p:txBody>
       </p:sp>
-      <p:pic>
-        <p:nvPicPr>
-          <p:cNvPr id="4" name="Image 0" descr="/tmp/figs/replication.png">    </p:cNvPr>
-          <p:cNvPicPr>
-            <a:picLocks noChangeAspect="1"/>
-          </p:cNvPicPr>
-          <p:nvPr/>
-        </p:nvPicPr>
-        <p:blipFill>
-          <a:blip r:embed="rId1"/>
-          <a:srcRect l="0" r="0" t="0" b="0"/>
-          <a:stretch/>
-        </p:blipFill>
-        <p:spPr>
-          <a:xfrm>
-            <a:off x="640080" y="1920240"/>
-            <a:ext cx="5852160" cy="3931920"/>
-          </a:xfrm>
-          <a:prstGeom prst="rect">
-            <a:avLst/>
-          </a:prstGeom>
-        </p:spPr>
-      </p:pic>
-      <p:sp>
-        <p:nvSpPr>
-          <p:cNvPr id="5" name="Text 2"/>
-          <p:cNvSpPr/>
-          <p:nvPr/>
-        </p:nvSpPr>
-        <p:spPr>
-          <a:xfrm>
-            <a:off x="6766560" y="2011680"/>
-            <a:ext cx="4754880" cy="4206240"/>
-          </a:xfrm>
-          <a:prstGeom prst="rect">
-            <a:avLst/>
-          </a:prstGeom>
-          <a:noFill/>
-          <a:ln/>
-        </p:spPr>
-        <p:txBody>
-          <a:bodyPr wrap="square" rtlCol="0" anchor="t"/>
-          <a:lstStyle/>
-          <a:p>
-            <a:pPr marL="152400" indent="-152400">
-              <a:lnSpc>
-                <a:spcPct val="115000"/>
-              </a:lnSpc>
-              <a:spcAft>
-                <a:spcPts val="1000"/>
-              </a:spcAft>
-              <a:buSzPct val="100000"/>
-              <a:buChar char="•"/>
-            </a:pPr>
-            <a:r>
-              <a:rPr lang="en-US" sz="1400" dirty="0">
+      <p:sp>
+        <p:nvSpPr>
+          <p:cNvPr id="4" name="Shape 2"/>
+          <p:cNvSpPr/>
+          <p:nvPr/>
+        </p:nvSpPr>
+        <p:spPr>
+          <a:xfrm>
+            <a:off x="640080" y="2011680"/>
+            <a:ext cx="10881360" cy="1188720"/>
+          </a:xfrm>
+          <a:prstGeom prst="roundRect">
+            <a:avLst>
+              <a:gd name="adj" fmla="val 7692"/>
+            </a:avLst>
+          </a:prstGeom>
+          <a:solidFill>
+            <a:srgbClr val="F4EEE8"/>
+          </a:solidFill>
+          <a:ln/>
+        </p:spPr>
+      </p:sp>
+      <p:sp>
+        <p:nvSpPr>
+          <p:cNvPr id="5" name="Text 3"/>
+          <p:cNvSpPr/>
+          <p:nvPr/>
+        </p:nvSpPr>
+        <p:spPr>
+          <a:xfrm>
+            <a:off x="960120" y="2103120"/>
+            <a:ext cx="2011680" cy="1005840"/>
+          </a:xfrm>
+          <a:prstGeom prst="rect">
+            <a:avLst/>
+          </a:prstGeom>
+          <a:noFill/>
+          <a:ln/>
+        </p:spPr>
+        <p:txBody>
+          <a:bodyPr wrap="square" lIns="0" tIns="0" rIns="0" bIns="0" rtlCol="0" anchor="ctr"/>
+          <a:lstStyle/>
+          <a:p>
+            <a:pPr indent="0" marL="0">
+              <a:buNone/>
+            </a:pPr>
+            <a:r>
+              <a:rPr lang="en-US" sz="1800" b="1" dirty="0">
+                <a:solidFill>
+                  <a:srgbClr val="7A3B2E"/>
+                </a:solidFill>
+                <a:latin typeface="Cambria" pitchFamily="34" charset="0"/>
+                <a:ea typeface="Cambria" pitchFamily="34" charset="-122"/>
+                <a:cs typeface="Cambria" pitchFamily="34" charset="-120"/>
+              </a:rPr>
+              <a:t>Selection</a:t>
+            </a:r>
+            <a:endParaRPr lang="en-US" sz="1800" dirty="0"/>
+          </a:p>
+        </p:txBody>
+      </p:sp>
+      <p:sp>
+        <p:nvSpPr>
+          <p:cNvPr id="6" name="Text 4"/>
+          <p:cNvSpPr/>
+          <p:nvPr/>
+        </p:nvSpPr>
+        <p:spPr>
+          <a:xfrm>
+            <a:off x="3108960" y="2103120"/>
+            <a:ext cx="8138160" cy="1005840"/>
+          </a:xfrm>
+          <a:prstGeom prst="rect">
+            <a:avLst/>
+          </a:prstGeom>
+          <a:noFill/>
+          <a:ln/>
+        </p:spPr>
+        <p:txBody>
+          <a:bodyPr wrap="square" lIns="0" tIns="0" rIns="0" bIns="0" rtlCol="0" anchor="ctr"/>
+          <a:lstStyle/>
+          <a:p>
+            <a:pPr indent="0" marL="0">
+              <a:buNone/>
+            </a:pPr>
+            <a:r>
+              <a:rPr lang="en-US" sz="1350" dirty="0">
                 <a:solidFill>
                   <a:srgbClr val="1A1A1A"/>
                 </a:solidFill>
@@ -4157,23 +4057,99 @@
                 <a:ea typeface="Calibri" pitchFamily="34" charset="-122"/>
                 <a:cs typeface="Calibri" pitchFamily="34" charset="-120"/>
               </a:rPr>
-              <a:t>Our sample run: absolutist words rise from ~8 to ~15 per 1,000 across fifteen years of one community. Trend r ≈ 0.8; shuffled years rarely match it.</a:t>
-            </a:r>
-            <a:endParaRPr lang="en-US" sz="1400" dirty="0"/>
-          </a:p>
-          <a:p>
-            <a:pPr marL="152400" indent="-152400">
-              <a:lnSpc>
-                <a:spcPct val="115000"/>
-              </a:lnSpc>
-              <a:spcAft>
-                <a:spcPts val="1000"/>
-              </a:spcAft>
-              <a:buSzPct val="100000"/>
-              <a:buChar char="•"/>
-            </a:pPr>
-            <a:r>
-              <a:rPr lang="en-US" sz="1400" dirty="0">
+              <a:t>We shuffle-tested our top keyness word: p = 0, guaranteed. We picked it FOR its extremity. State the hypothesis before looking.</a:t>
+            </a:r>
+            <a:endParaRPr lang="en-US" sz="1350" dirty="0"/>
+          </a:p>
+        </p:txBody>
+      </p:sp>
+      <p:sp>
+        <p:nvSpPr>
+          <p:cNvPr id="7" name="Shape 5"/>
+          <p:cNvSpPr/>
+          <p:nvPr/>
+        </p:nvSpPr>
+        <p:spPr>
+          <a:xfrm>
+            <a:off x="640080" y="3383280"/>
+            <a:ext cx="10881360" cy="1188720"/>
+          </a:xfrm>
+          <a:prstGeom prst="roundRect">
+            <a:avLst>
+              <a:gd name="adj" fmla="val 7692"/>
+            </a:avLst>
+          </a:prstGeom>
+          <a:solidFill>
+            <a:srgbClr val="F4EEE8"/>
+          </a:solidFill>
+          <a:ln/>
+        </p:spPr>
+      </p:sp>
+      <p:sp>
+        <p:nvSpPr>
+          <p:cNvPr id="8" name="Text 6"/>
+          <p:cNvSpPr/>
+          <p:nvPr/>
+        </p:nvSpPr>
+        <p:spPr>
+          <a:xfrm>
+            <a:off x="960120" y="3474720"/>
+            <a:ext cx="2011680" cy="1005840"/>
+          </a:xfrm>
+          <a:prstGeom prst="rect">
+            <a:avLst/>
+          </a:prstGeom>
+          <a:noFill/>
+          <a:ln/>
+        </p:spPr>
+        <p:txBody>
+          <a:bodyPr wrap="square" lIns="0" tIns="0" rIns="0" bIns="0" rtlCol="0" anchor="ctr"/>
+          <a:lstStyle/>
+          <a:p>
+            <a:pPr indent="0" marL="0">
+              <a:buNone/>
+            </a:pPr>
+            <a:r>
+              <a:rPr lang="en-US" sz="1800" b="1" dirty="0">
+                <a:solidFill>
+                  <a:srgbClr val="B9852F"/>
+                </a:solidFill>
+                <a:latin typeface="Cambria" pitchFamily="34" charset="0"/>
+                <a:ea typeface="Cambria" pitchFamily="34" charset="-122"/>
+                <a:cs typeface="Cambria" pitchFamily="34" charset="-120"/>
+              </a:rPr>
+              <a:t>Multiplicity</a:t>
+            </a:r>
+            <a:endParaRPr lang="en-US" sz="1800" dirty="0"/>
+          </a:p>
+        </p:txBody>
+      </p:sp>
+      <p:sp>
+        <p:nvSpPr>
+          <p:cNvPr id="9" name="Text 7"/>
+          <p:cNvSpPr/>
+          <p:nvPr/>
+        </p:nvSpPr>
+        <p:spPr>
+          <a:xfrm>
+            <a:off x="3108960" y="3474720"/>
+            <a:ext cx="8138160" cy="1005840"/>
+          </a:xfrm>
+          <a:prstGeom prst="rect">
+            <a:avLst/>
+          </a:prstGeom>
+          <a:noFill/>
+          <a:ln/>
+        </p:spPr>
+        <p:txBody>
+          <a:bodyPr wrap="square" lIns="0" tIns="0" rIns="0" bIns="0" rtlCol="0" anchor="ctr"/>
+          <a:lstStyle/>
+          <a:p>
+            <a:pPr indent="0" marL="0">
+              <a:buNone/>
+            </a:pPr>
+            <a:r>
+              <a:rPr lang="en-US" sz="1350" dirty="0">
                 <a:solidFill>
                   <a:srgbClr val="1A1A1A"/>
                 </a:solidFill>
@@ -4181,23 +4157,99 @@
                 <a:ea typeface="Calibri" pitchFamily="34" charset="-122"/>
                 <a:cs typeface="Calibri" pitchFamily="34" charset="-120"/>
               </a:rPr>
-              <a:t>Evidence the composition story cannot explain. Not proof of sadness: AskReddit's users drifted, the proxy is 19 words, each point is a few hundred comments (the error bars say so).</a:t>
-            </a:r>
-            <a:endParaRPr lang="en-US" sz="1400" dirty="0"/>
-          </a:p>
-          <a:p>
-            <a:pPr marL="152400" indent="-152400">
-              <a:lnSpc>
-                <a:spcPct val="115000"/>
-              </a:lnSpc>
-              <a:spcAft>
-                <a:spcPts val="1000"/>
-              </a:spcAft>
-              <a:buSzPct val="100000"/>
-              <a:buChar char="•"/>
-            </a:pPr>
-            <a:r>
-              <a:rPr lang="en-US" sz="1400" dirty="0">
+              <a:t>Split one community randomly in half: keyness still returns a convincing “distinctive vocabulary.” Pure noise. 1,500 words at p &lt; .05: ~75 pass by luck.</a:t>
+            </a:r>
+            <a:endParaRPr lang="en-US" sz="1350" dirty="0"/>
+          </a:p>
+        </p:txBody>
+      </p:sp>
+      <p:sp>
+        <p:nvSpPr>
+          <p:cNvPr id="10" name="Shape 8"/>
+          <p:cNvSpPr/>
+          <p:nvPr/>
+        </p:nvSpPr>
+        <p:spPr>
+          <a:xfrm>
+            <a:off x="640080" y="4754880"/>
+            <a:ext cx="10881360" cy="1188720"/>
+          </a:xfrm>
+          <a:prstGeom prst="roundRect">
+            <a:avLst>
+              <a:gd name="adj" fmla="val 7692"/>
+            </a:avLst>
+          </a:prstGeom>
+          <a:solidFill>
+            <a:srgbClr val="F4EEE8"/>
+          </a:solidFill>
+          <a:ln/>
+        </p:spPr>
+      </p:sp>
+      <p:sp>
+        <p:nvSpPr>
+          <p:cNvPr id="11" name="Text 9"/>
+          <p:cNvSpPr/>
+          <p:nvPr/>
+        </p:nvSpPr>
+        <p:spPr>
+          <a:xfrm>
+            <a:off x="960120" y="4846320"/>
+            <a:ext cx="2011680" cy="1005840"/>
+          </a:xfrm>
+          <a:prstGeom prst="rect">
+            <a:avLst/>
+          </a:prstGeom>
+          <a:noFill/>
+          <a:ln/>
+        </p:spPr>
+        <p:txBody>
+          <a:bodyPr wrap="square" lIns="0" tIns="0" rIns="0" bIns="0" rtlCol="0" anchor="ctr"/>
+          <a:lstStyle/>
+          <a:p>
+            <a:pPr indent="0" marL="0">
+              <a:buNone/>
+            </a:pPr>
+            <a:r>
+              <a:rPr lang="en-US" sz="1800" b="1" dirty="0">
+                <a:solidFill>
+                  <a:srgbClr val="2E5F8A"/>
+                </a:solidFill>
+                <a:latin typeface="Cambria" pitchFamily="34" charset="0"/>
+                <a:ea typeface="Cambria" pitchFamily="34" charset="-122"/>
+                <a:cs typeface="Cambria" pitchFamily="34" charset="-120"/>
+              </a:rPr>
+              <a:t>Size</a:t>
+            </a:r>
+            <a:endParaRPr lang="en-US" sz="1800" dirty="0"/>
+          </a:p>
+        </p:txBody>
+      </p:sp>
+      <p:sp>
+        <p:nvSpPr>
+          <p:cNvPr id="12" name="Text 10"/>
+          <p:cNvSpPr/>
+          <p:nvPr/>
+        </p:nvSpPr>
+        <p:spPr>
+          <a:xfrm>
+            <a:off x="3108960" y="4846320"/>
+            <a:ext cx="8138160" cy="1005840"/>
+          </a:xfrm>
+          <a:prstGeom prst="rect">
+            <a:avLst/>
+          </a:prstGeom>
+          <a:noFill/>
+          <a:ln/>
+        </p:spPr>
+        <p:txBody>
+          <a:bodyPr wrap="square" lIns="0" tIns="0" rIns="0" bIns="0" rtlCol="0" anchor="ctr"/>
+          <a:lstStyle/>
+          <a:p>
+            <a:pPr indent="0" marL="0">
+              <a:buNone/>
+            </a:pPr>
+            <a:r>
+              <a:rPr lang="en-US" sz="1350" dirty="0">
                 <a:solidFill>
                   <a:srgbClr val="1A1A1A"/>
                 </a:solidFill>
@@ -4205,9 +4257,9 @@
                 <a:ea typeface="Calibri" pitchFamily="34" charset="-122"/>
                 <a:cs typeface="Calibri" pitchFamily="34" charset="-120"/>
               </a:rPr>
-              <a:t>What survives a second community, another word list, and bigger samples, you may say out loud.</a:t>
-            </a:r>
-            <a:endParaRPr lang="en-US" sz="1400" dirty="0"/>
+              <a:t>“Significant” answers “is it chance?”, never “does it matter?” Report the effect and the p, together, with the bootstrap's interval around the effect.</a:t>
+            </a:r>
+            <a:endParaRPr lang="en-US" sz="1350" dirty="0"/>
           </a:p>
         </p:txBody>
       </p:sp>
@@ -4276,7 +4328,7 @@
                 <a:ea typeface="Calibri" pitchFamily="34" charset="-122"/>
                 <a:cs typeface="Calibri" pitchFamily="34" charset="-120"/>
               </a:rPr>
-              <a:t>DISCUSSION · COUNTING</a:t>
+              <a:t>THE REPLICATION · YOURS</a:t>
             </a:r>
             <a:endParaRPr lang="en-US" sz="1300" dirty="0"/>
           </a:p>
@@ -4315,7 +4367,7 @@
                 <a:ea typeface="Cambria" pitchFamily="34" charset="-122"/>
                 <a:cs typeface="Cambria" pitchFamily="34" charset="-120"/>
               </a:rPr>
-              <a:t>What did the count actually measure?</a:t>
+              <a:t>Bollen on Reddit: hold the community fixed</a:t>
             </a:r>
             <a:endParaRPr lang="en-US" sz="3400" dirty="0"/>
           </a:p>
@@ -4323,18 +4375,136 @@
       </p:sp>
       <p:sp>
         <p:nvSpPr>
-          <p:cNvPr id="4" name="Shape 2"/>
+          <p:cNvPr id="4" name="Text 2"/>
           <p:cNvSpPr/>
           <p:nvPr/>
         </p:nvSpPr>
         <p:spPr>
           <a:xfrm>
             <a:off x="640080" y="2011680"/>
-            <a:ext cx="10881360" cy="1188720"/>
+            <a:ext cx="4937760" cy="4206240"/>
+          </a:xfrm>
+          <a:prstGeom prst="rect">
+            <a:avLst/>
+          </a:prstGeom>
+          <a:noFill/>
+          <a:ln/>
+        </p:spPr>
+        <p:txBody>
+          <a:bodyPr wrap="square" rtlCol="0" anchor="t"/>
+          <a:lstStyle/>
+          <a:p>
+            <a:pPr marL="152400" indent="-152400">
+              <a:lnSpc>
+                <a:spcPct val="115000"/>
+              </a:lnSpc>
+              <a:spcAft>
+                <a:spcPts val="1000"/>
+              </a:spcAft>
+              <a:buSzPct val="100000"/>
+              <a:buChar char="•"/>
+            </a:pPr>
+            <a:r>
+              <a:rPr lang="en-US" sz="1500" dirty="0">
+                <a:solidFill>
+                  <a:srgbClr val="1A1A1A"/>
+                </a:solidFill>
+                <a:latin typeface="Calibri" pitchFamily="34" charset="0"/>
+                <a:ea typeface="Calibri" pitchFamily="34" charset="-122"/>
+                <a:cs typeface="Calibri" pitchFamily="34" charset="-120"/>
+              </a:rPr>
+              <a:t>Schmidt's demand, satisfied: one subreddit, fifteen years, only the year varies. Composition cannot write this trend.</a:t>
+            </a:r>
+            <a:endParaRPr lang="en-US" sz="1500" dirty="0"/>
+          </a:p>
+          <a:p>
+            <a:pPr marL="152400" indent="-152400">
+              <a:lnSpc>
+                <a:spcPct val="115000"/>
+              </a:lnSpc>
+              <a:spcAft>
+                <a:spcPts val="1000"/>
+              </a:spcAft>
+              <a:buSzPct val="100000"/>
+              <a:buChar char="•"/>
+            </a:pPr>
+            <a:r>
+              <a:rPr lang="en-US" sz="1500" dirty="0">
+                <a:solidFill>
+                  <a:srgbClr val="1A1A1A"/>
+                </a:solidFill>
+                <a:latin typeface="Calibri" pitchFamily="34" charset="0"/>
+                <a:ea typeface="Calibri" pitchFamily="34" charset="-122"/>
+                <a:cs typeface="Calibri" pitchFamily="34" charset="-120"/>
+              </a:rPr>
+              <a:t>The honest adaptation: the paper's phrases are too rare for our samples, so we count the absolutist index (always, never, nothing...), 19 words that track distress language (Al-Mosaiwi &amp; Johnstone 2018).</a:t>
+            </a:r>
+            <a:endParaRPr lang="en-US" sz="1500" dirty="0"/>
+          </a:p>
+          <a:p>
+            <a:pPr marL="152400" indent="-152400">
+              <a:lnSpc>
+                <a:spcPct val="115000"/>
+              </a:lnSpc>
+              <a:spcAft>
+                <a:spcPts val="1000"/>
+              </a:spcAft>
+              <a:buSzPct val="100000"/>
+              <a:buChar char="•"/>
+            </a:pPr>
+            <a:r>
+              <a:rPr lang="en-US" sz="1500" dirty="0">
+                <a:solidFill>
+                  <a:srgbClr val="1A1A1A"/>
+                </a:solidFill>
+                <a:latin typeface="Calibri" pitchFamily="34" charset="0"/>
+                <a:ea typeface="Calibri" pitchFamily="34" charset="-122"/>
+                <a:cs typeface="Calibri" pitchFamily="34" charset="-120"/>
+              </a:rPr>
+              <a:t>The room's protocol: predict the shape out loud → run the default together → each pair swaps in a community they know → bring the plot back.</a:t>
+            </a:r>
+            <a:endParaRPr lang="en-US" sz="1500" dirty="0"/>
+          </a:p>
+          <a:p>
+            <a:pPr marL="152400" indent="-152400">
+              <a:lnSpc>
+                <a:spcPct val="115000"/>
+              </a:lnSpc>
+              <a:spcAft>
+                <a:spcPts val="1000"/>
+              </a:spcAft>
+              <a:buSzPct val="100000"/>
+              <a:buChar char="•"/>
+            </a:pPr>
+            <a:r>
+              <a:rPr lang="en-US" sz="1500" dirty="0">
+                <a:solidFill>
+                  <a:srgbClr val="1A1A1A"/>
+                </a:solidFill>
+                <a:latin typeface="Calibri" pitchFamily="34" charset="0"/>
+                <a:ea typeface="Calibri" pitchFamily="34" charset="-122"/>
+                <a:cs typeface="Calibri" pitchFamily="34" charset="-120"/>
+              </a:rPr>
+              <a:t>Ten plots from ten communities is a real replication study, made in one classroom.</a:t>
+            </a:r>
+            <a:endParaRPr lang="en-US" sz="1500" dirty="0"/>
+          </a:p>
+        </p:txBody>
+      </p:sp>
+      <p:sp>
+        <p:nvSpPr>
+          <p:cNvPr id="5" name="Shape 3"/>
+          <p:cNvSpPr/>
+          <p:nvPr/>
+        </p:nvSpPr>
+        <p:spPr>
+          <a:xfrm>
+            <a:off x="5852160" y="2011680"/>
+            <a:ext cx="5669280" cy="3657600"/>
           </a:xfrm>
           <a:prstGeom prst="roundRect">
             <a:avLst>
-              <a:gd name="adj" fmla="val 7692"/>
+              <a:gd name="adj" fmla="val 2500"/>
             </a:avLst>
           </a:prstGeom>
           <a:solidFill>
@@ -4345,34 +4515,53 @@
       </p:sp>
       <p:sp>
         <p:nvSpPr>
-          <p:cNvPr id="5" name="Shape 3"/>
-          <p:cNvSpPr/>
-          <p:nvPr/>
-        </p:nvSpPr>
-        <p:spPr>
-          <a:xfrm>
-            <a:off x="914400" y="2331720"/>
-            <a:ext cx="320040" cy="320040"/>
-          </a:xfrm>
-          <a:prstGeom prst="ellipse">
-            <a:avLst/>
-          </a:prstGeom>
-          <a:solidFill>
-            <a:srgbClr val="7A3B2E"/>
-          </a:solidFill>
-          <a:ln/>
-        </p:spPr>
-      </p:sp>
-      <p:sp>
-        <p:nvSpPr>
           <p:cNvPr id="6" name="Text 4"/>
           <p:cNvSpPr/>
           <p:nvPr/>
         </p:nvSpPr>
         <p:spPr>
           <a:xfrm>
-            <a:off x="1463040" y="2103120"/>
-            <a:ext cx="9784080" cy="1005840"/>
+            <a:off x="6126480" y="2286000"/>
+            <a:ext cx="5120640" cy="320040"/>
+          </a:xfrm>
+          <a:prstGeom prst="rect">
+            <a:avLst/>
+          </a:prstGeom>
+          <a:noFill/>
+          <a:ln/>
+        </p:spPr>
+        <p:txBody>
+          <a:bodyPr wrap="square" rtlCol="0" anchor="ctr"/>
+          <a:lstStyle/>
+          <a:p>
+            <a:pPr indent="0" marL="0">
+              <a:buNone/>
+            </a:pPr>
+            <a:r>
+              <a:rPr lang="en-US" sz="1200" b="1" spc="200" kern="0" dirty="0">
+                <a:solidFill>
+                  <a:srgbClr val="6B6B63"/>
+                </a:solidFill>
+                <a:latin typeface="Calibri" pitchFamily="34" charset="0"/>
+                <a:ea typeface="Calibri" pitchFamily="34" charset="-122"/>
+                <a:cs typeface="Calibri" pitchFamily="34" charset="-120"/>
+              </a:rPr>
+              <a:t>the design, in one line</a:t>
+            </a:r>
+            <a:endParaRPr lang="en-US" sz="1200" dirty="0"/>
+          </a:p>
+        </p:txBody>
+      </p:sp>
+      <p:sp>
+        <p:nvSpPr>
+          <p:cNvPr id="7" name="Text 5"/>
+          <p:cNvSpPr/>
+          <p:nvPr/>
+        </p:nvSpPr>
+        <p:spPr>
+          <a:xfrm>
+            <a:off x="6126480" y="2743200"/>
+            <a:ext cx="5120640" cy="1097280"/>
           </a:xfrm>
           <a:prstGeom prst="rect">
             <a:avLst/>
@@ -4388,72 +4577,47 @@
               <a:buNone/>
             </a:pPr>
             <a:r>
-              <a:rPr lang="en-US" sz="1500" i="1" dirty="0">
+              <a:rPr lang="en-US" sz="1500" dirty="0">
                 <a:solidFill>
                   <a:srgbClr val="1A1A1A"/>
                 </a:solidFill>
-                <a:latin typeface="Cambria" pitchFamily="34" charset="0"/>
-                <a:ea typeface="Cambria" pitchFamily="34" charset="-122"/>
-                <a:cs typeface="Cambria" pitchFamily="34" charset="-120"/>
-              </a:rPr>
-              <a:t>Absolutist words rose. List every explanation you can: feelings, phone keyboards, age of users, comment length, moderation. Which could you test with today's tools?</a:t>
+                <a:latin typeface="Courier New" pitchFamily="34" charset="0"/>
+                <a:ea typeface="Courier New" pitchFamily="34" charset="-122"/>
+                <a:cs typeface="Courier New" pitchFamily="34" charset="-120"/>
+              </a:rPr>
+              <a:t>rate(absolutist words | r/AskReddit, year)</a:t>
             </a:r>
             <a:endParaRPr lang="en-US" sz="1500" dirty="0"/>
           </a:p>
-        </p:txBody>
-      </p:sp>
-      <p:sp>
-        <p:nvSpPr>
-          <p:cNvPr id="7" name="Shape 5"/>
-          <p:cNvSpPr/>
-          <p:nvPr/>
-        </p:nvSpPr>
-        <p:spPr>
-          <a:xfrm>
-            <a:off x="640080" y="3383280"/>
-            <a:ext cx="10881360" cy="1188720"/>
-          </a:xfrm>
-          <a:prstGeom prst="roundRect">
-            <a:avLst>
-              <a:gd name="adj" fmla="val 7692"/>
-            </a:avLst>
-          </a:prstGeom>
-          <a:solidFill>
-            <a:srgbClr val="F4EEE8"/>
-          </a:solidFill>
-          <a:ln/>
-        </p:spPr>
-      </p:sp>
-      <p:sp>
-        <p:nvSpPr>
-          <p:cNvPr id="8" name="Shape 6"/>
-          <p:cNvSpPr/>
-          <p:nvPr/>
-        </p:nvSpPr>
-        <p:spPr>
-          <a:xfrm>
-            <a:off x="914400" y="3703320"/>
-            <a:ext cx="320040" cy="320040"/>
-          </a:xfrm>
-          <a:prstGeom prst="ellipse">
-            <a:avLst/>
-          </a:prstGeom>
-          <a:solidFill>
-            <a:srgbClr val="B9852F"/>
-          </a:solidFill>
-          <a:ln/>
-        </p:spPr>
-      </p:sp>
-      <p:sp>
-        <p:nvSpPr>
-          <p:cNvPr id="9" name="Text 7"/>
-          <p:cNvSpPr/>
-          <p:nvPr/>
-        </p:nvSpPr>
-        <p:spPr>
-          <a:xfrm>
-            <a:off x="1463040" y="3474720"/>
-            <a:ext cx="9784080" cy="1005840"/>
+          <a:p>
+            <a:pPr indent="0" marL="0">
+              <a:buNone/>
+            </a:pPr>
+            <a:r>
+              <a:rPr lang="en-US" sz="1500" dirty="0">
+                <a:solidFill>
+                  <a:srgbClr val="1A1A1A"/>
+                </a:solidFill>
+                <a:latin typeface="Courier New" pitchFamily="34" charset="0"/>
+                <a:ea typeface="Courier New" pitchFamily="34" charset="-122"/>
+                <a:cs typeface="Courier New" pitchFamily="34" charset="-120"/>
+              </a:rPr>
+              <a:t>for year in 2010 … 2024</a:t>
+            </a:r>
+            <a:endParaRPr lang="en-US" sz="1500" dirty="0"/>
+          </a:p>
+        </p:txBody>
+      </p:sp>
+      <p:sp>
+        <p:nvSpPr>
+          <p:cNvPr id="8" name="Text 6"/>
+          <p:cNvSpPr/>
+          <p:nvPr/>
+        </p:nvSpPr>
+        <p:spPr>
+          <a:xfrm>
+            <a:off x="6126480" y="4023360"/>
+            <a:ext cx="5120640" cy="1280160"/>
           </a:xfrm>
           <a:prstGeom prst="rect">
             <a:avLst/>
@@ -4469,98 +4633,34 @@
               <a:buNone/>
             </a:pPr>
             <a:r>
-              <a:rPr lang="en-US" sz="1500" i="1" dirty="0">
+              <a:rPr lang="en-US" sz="1400" i="1" dirty="0">
                 <a:solidFill>
                   <a:srgbClr val="1A1A1A"/>
                 </a:solidFill>
-                <a:latin typeface="Cambria" pitchFamily="34" charset="0"/>
-                <a:ea typeface="Cambria" pitchFamily="34" charset="-122"/>
-                <a:cs typeface="Cambria" pitchFamily="34" charset="-120"/>
-              </a:rPr>
-              <a:t>Daniels ranked rappers by unique words. Aesop Rock wins. What is the number a measurement OF: skill, genre, era, or the denominator?</a:t>
-            </a:r>
-            <a:endParaRPr lang="en-US" sz="1500" dirty="0"/>
-          </a:p>
-        </p:txBody>
-      </p:sp>
-      <p:sp>
-        <p:nvSpPr>
-          <p:cNvPr id="10" name="Shape 8"/>
-          <p:cNvSpPr/>
-          <p:nvPr/>
-        </p:nvSpPr>
-        <p:spPr>
-          <a:xfrm>
-            <a:off x="640080" y="4754880"/>
-            <a:ext cx="10881360" cy="1188720"/>
-          </a:xfrm>
-          <a:prstGeom prst="roundRect">
-            <a:avLst>
-              <a:gd name="adj" fmla="val 7692"/>
-            </a:avLst>
-          </a:prstGeom>
-          <a:solidFill>
-            <a:srgbClr val="F4EEE8"/>
-          </a:solidFill>
-          <a:ln/>
-        </p:spPr>
-      </p:sp>
-      <p:sp>
-        <p:nvSpPr>
-          <p:cNvPr id="11" name="Shape 9"/>
-          <p:cNvSpPr/>
-          <p:nvPr/>
-        </p:nvSpPr>
-        <p:spPr>
-          <a:xfrm>
-            <a:off x="914400" y="5074920"/>
-            <a:ext cx="320040" cy="320040"/>
-          </a:xfrm>
-          <a:prstGeom prst="ellipse">
-            <a:avLst/>
-          </a:prstGeom>
-          <a:solidFill>
-            <a:srgbClr val="3F6F5F"/>
-          </a:solidFill>
-          <a:ln/>
-        </p:spPr>
-      </p:sp>
-      <p:sp>
-        <p:nvSpPr>
-          <p:cNvPr id="12" name="Text 10"/>
-          <p:cNvSpPr/>
-          <p:nvPr/>
-        </p:nvSpPr>
-        <p:spPr>
-          <a:xfrm>
-            <a:off x="1463040" y="4846320"/>
-            <a:ext cx="9784080" cy="1005840"/>
-          </a:xfrm>
-          <a:prstGeom prst="rect">
-            <a:avLst/>
-          </a:prstGeom>
-          <a:noFill/>
-          <a:ln/>
-        </p:spPr>
-        <p:txBody>
-          <a:bodyPr wrap="square" lIns="0" tIns="0" rIns="0" bIns="0" rtlCol="0" anchor="ctr"/>
-          <a:lstStyle/>
-          <a:p>
-            <a:pPr indent="0" marL="0">
-              <a:buNone/>
-            </a:pPr>
-            <a:r>
-              <a:rPr lang="en-US" sz="1500" i="1" dirty="0">
+                <a:latin typeface="Calibri" pitchFamily="34" charset="0"/>
+                <a:ea typeface="Calibri" pitchFamily="34" charset="-122"/>
+                <a:cs typeface="Calibri" pitchFamily="34" charset="-120"/>
+              </a:rPr>
+              <a:t>…then the trend itself goes on trial:</a:t>
+            </a:r>
+            <a:endParaRPr lang="en-US" sz="1400" dirty="0"/>
+          </a:p>
+          <a:p>
+            <a:pPr indent="0" marL="0">
+              <a:buNone/>
+            </a:pPr>
+            <a:r>
+              <a:rPr lang="en-US" sz="1400" i="1" dirty="0">
                 <a:solidFill>
                   <a:srgbClr val="1A1A1A"/>
                 </a:solidFill>
-                <a:latin typeface="Cambria" pitchFamily="34" charset="0"/>
-                <a:ea typeface="Cambria" pitchFamily="34" charset="-122"/>
-                <a:cs typeface="Cambria" pitchFamily="34" charset="-120"/>
-              </a:rPr>
-              <a:t>When is a zero a fact, and when is it a small sample? (Recall: “money” appeared 0 times in one gardening pull.)</a:t>
-            </a:r>
-            <a:endParaRPr lang="en-US" sz="1500" dirty="0"/>
+                <a:latin typeface="Calibri" pitchFamily="34" charset="0"/>
+                <a:ea typeface="Calibri" pitchFamily="34" charset="-122"/>
+                <a:cs typeface="Calibri" pitchFamily="34" charset="-120"/>
+              </a:rPr>
+              <a:t>correlate with year, and shuffle the years 1,000 times.</a:t>
+            </a:r>
+            <a:endParaRPr lang="en-US" sz="1400" dirty="0"/>
           </a:p>
         </p:txBody>
       </p:sp>
@@ -4623,13 +4723,13 @@
             <a:r>
               <a:rPr lang="en-US" sz="1300" b="1" spc="300" kern="0" dirty="0">
                 <a:solidFill>
-                  <a:srgbClr val="2E5F8A"/>
+                  <a:srgbClr val="B9852F"/>
                 </a:solidFill>
                 <a:latin typeface="Calibri" pitchFamily="34" charset="0"/>
                 <a:ea typeface="Calibri" pitchFamily="34" charset="-122"/>
                 <a:cs typeface="Calibri" pitchFamily="34" charset="-120"/>
               </a:rPr>
-              <a:t>DISCUSSION · VECTORS AND TRUTH</a:t>
+              <a:t>THE REPLICATION · A SAMPLE RUN</a:t>
             </a:r>
             <a:endParaRPr lang="en-US" sz="1300" dirty="0"/>
           </a:p>
@@ -4668,333 +4768,126 @@
                 <a:ea typeface="Cambria" pitchFamily="34" charset="-122"/>
                 <a:cs typeface="Cambria" pitchFamily="34" charset="-120"/>
               </a:rPr>
-              <a:t>When numbers stand in for meaning</a:t>
+              <a:t>It climbs here too, with composition controlled</a:t>
             </a:r>
             <a:endParaRPr lang="en-US" sz="3400" dirty="0"/>
           </a:p>
         </p:txBody>
       </p:sp>
-      <p:sp>
-        <p:nvSpPr>
-          <p:cNvPr id="4" name="Shape 2"/>
-          <p:cNvSpPr/>
-          <p:nvPr/>
-        </p:nvSpPr>
-        <p:spPr>
-          <a:xfrm>
-            <a:off x="640080" y="1783080"/>
-            <a:ext cx="10881360" cy="1024128"/>
-          </a:xfrm>
-          <a:prstGeom prst="roundRect">
-            <a:avLst>
-              <a:gd name="adj" fmla="val 8929"/>
-            </a:avLst>
-          </a:prstGeom>
-          <a:solidFill>
-            <a:srgbClr val="F4EEE8"/>
-          </a:solidFill>
-          <a:ln/>
-        </p:spPr>
-      </p:sp>
-      <p:sp>
-        <p:nvSpPr>
-          <p:cNvPr id="5" name="Shape 3"/>
-          <p:cNvSpPr/>
-          <p:nvPr/>
-        </p:nvSpPr>
-        <p:spPr>
-          <a:xfrm>
-            <a:off x="914400" y="2057400"/>
-            <a:ext cx="292608" cy="292608"/>
-          </a:xfrm>
-          <a:prstGeom prst="ellipse">
-            <a:avLst/>
-          </a:prstGeom>
-          <a:solidFill>
-            <a:srgbClr val="2E5F8A"/>
-          </a:solidFill>
-          <a:ln/>
-        </p:spPr>
-      </p:sp>
-      <p:sp>
-        <p:nvSpPr>
-          <p:cNvPr id="6" name="Text 4"/>
-          <p:cNvSpPr/>
-          <p:nvPr/>
-        </p:nvSpPr>
-        <p:spPr>
-          <a:xfrm>
-            <a:off x="1417320" y="1847088"/>
-            <a:ext cx="9875520" cy="896112"/>
-          </a:xfrm>
-          <a:prstGeom prst="rect">
-            <a:avLst/>
-          </a:prstGeom>
-          <a:noFill/>
-          <a:ln/>
-        </p:spPr>
-        <p:txBody>
-          <a:bodyPr wrap="square" lIns="0" tIns="0" rIns="0" bIns="0" rtlCol="0" anchor="ctr"/>
-          <a:lstStyle/>
-          <a:p>
-            <a:pPr indent="0" marL="0">
-              <a:buNone/>
-            </a:pPr>
-            <a:r>
-              <a:rPr lang="en-US" sz="1350" i="1" dirty="0">
+      <p:pic>
+        <p:nvPicPr>
+          <p:cNvPr id="4" name="Image 0" descr="/tmp/figs/replication.png">    </p:cNvPr>
+          <p:cNvPicPr>
+            <a:picLocks noChangeAspect="1"/>
+          </p:cNvPicPr>
+          <p:nvPr/>
+        </p:nvPicPr>
+        <p:blipFill>
+          <a:blip r:embed="rId1"/>
+          <a:srcRect l="0" r="0" t="0" b="0"/>
+          <a:stretch/>
+        </p:blipFill>
+        <p:spPr>
+          <a:xfrm>
+            <a:off x="640080" y="1920240"/>
+            <a:ext cx="5852160" cy="3931920"/>
+          </a:xfrm>
+          <a:prstGeom prst="rect">
+            <a:avLst/>
+          </a:prstGeom>
+        </p:spPr>
+      </p:pic>
+      <p:sp>
+        <p:nvSpPr>
+          <p:cNvPr id="5" name="Text 2"/>
+          <p:cNvSpPr/>
+          <p:nvPr/>
+        </p:nvSpPr>
+        <p:spPr>
+          <a:xfrm>
+            <a:off x="6766560" y="2011680"/>
+            <a:ext cx="4754880" cy="4206240"/>
+          </a:xfrm>
+          <a:prstGeom prst="rect">
+            <a:avLst/>
+          </a:prstGeom>
+          <a:noFill/>
+          <a:ln/>
+        </p:spPr>
+        <p:txBody>
+          <a:bodyPr wrap="square" rtlCol="0" anchor="t"/>
+          <a:lstStyle/>
+          <a:p>
+            <a:pPr marL="152400" indent="-152400">
+              <a:lnSpc>
+                <a:spcPct val="115000"/>
+              </a:lnSpc>
+              <a:spcAft>
+                <a:spcPts val="1000"/>
+              </a:spcAft>
+              <a:buSzPct val="100000"/>
+              <a:buChar char="•"/>
+            </a:pPr>
+            <a:r>
+              <a:rPr lang="en-US" sz="1400" dirty="0">
                 <a:solidFill>
                   <a:srgbClr val="1A1A1A"/>
                 </a:solidFill>
-                <a:latin typeface="Cambria" pitchFamily="34" charset="0"/>
-                <a:ea typeface="Cambria" pitchFamily="34" charset="-122"/>
-                <a:cs typeface="Cambria" pitchFamily="34" charset="-120"/>
-              </a:rPr>
-              <a:t>A comment became a row of numbers, a community a cloud of points. What survived the translation, and what did not? Give one example of each.</a:t>
-            </a:r>
-            <a:endParaRPr lang="en-US" sz="1350" dirty="0"/>
-          </a:p>
-        </p:txBody>
-      </p:sp>
-      <p:sp>
-        <p:nvSpPr>
-          <p:cNvPr id="7" name="Shape 5"/>
-          <p:cNvSpPr/>
-          <p:nvPr/>
-        </p:nvSpPr>
-        <p:spPr>
-          <a:xfrm>
-            <a:off x="640080" y="2953512"/>
-            <a:ext cx="10881360" cy="1024128"/>
-          </a:xfrm>
-          <a:prstGeom prst="roundRect">
-            <a:avLst>
-              <a:gd name="adj" fmla="val 8929"/>
-            </a:avLst>
-          </a:prstGeom>
-          <a:solidFill>
-            <a:srgbClr val="F4EEE8"/>
-          </a:solidFill>
-          <a:ln/>
-        </p:spPr>
-      </p:sp>
-      <p:sp>
-        <p:nvSpPr>
-          <p:cNvPr id="8" name="Shape 6"/>
-          <p:cNvSpPr/>
-          <p:nvPr/>
-        </p:nvSpPr>
-        <p:spPr>
-          <a:xfrm>
-            <a:off x="914400" y="3227832"/>
-            <a:ext cx="292608" cy="292608"/>
-          </a:xfrm>
-          <a:prstGeom prst="ellipse">
-            <a:avLst/>
-          </a:prstGeom>
-          <a:solidFill>
-            <a:srgbClr val="3F6F5F"/>
-          </a:solidFill>
-          <a:ln/>
-        </p:spPr>
-      </p:sp>
-      <p:sp>
-        <p:nvSpPr>
-          <p:cNvPr id="9" name="Text 7"/>
-          <p:cNvSpPr/>
-          <p:nvPr/>
-        </p:nvSpPr>
-        <p:spPr>
-          <a:xfrm>
-            <a:off x="1417320" y="3017520"/>
-            <a:ext cx="9875520" cy="896112"/>
-          </a:xfrm>
-          <a:prstGeom prst="rect">
-            <a:avLst/>
-          </a:prstGeom>
-          <a:noFill/>
-          <a:ln/>
-        </p:spPr>
-        <p:txBody>
-          <a:bodyPr wrap="square" lIns="0" tIns="0" rIns="0" bIns="0" rtlCol="0" anchor="ctr"/>
-          <a:lstStyle/>
-          <a:p>
-            <a:pPr indent="0" marL="0">
-              <a:buNone/>
-            </a:pPr>
-            <a:r>
-              <a:rPr lang="en-US" sz="1350" i="1" dirty="0">
+                <a:latin typeface="Calibri" pitchFamily="34" charset="0"/>
+                <a:ea typeface="Calibri" pitchFamily="34" charset="-122"/>
+                <a:cs typeface="Calibri" pitchFamily="34" charset="-120"/>
+              </a:rPr>
+              <a:t>Our sample run: absolutist words climb from ~8 toward ~15 per 1,000 across fifteen years of one community. Trend r ≈ 0.8; shuffled years rarely match it.</a:t>
+            </a:r>
+            <a:endParaRPr lang="en-US" sz="1400" dirty="0"/>
+          </a:p>
+          <a:p>
+            <a:pPr marL="152400" indent="-152400">
+              <a:lnSpc>
+                <a:spcPct val="115000"/>
+              </a:lnSpc>
+              <a:spcAft>
+                <a:spcPts val="1000"/>
+              </a:spcAft>
+              <a:buSzPct val="100000"/>
+              <a:buChar char="•"/>
+            </a:pPr>
+            <a:r>
+              <a:rPr lang="en-US" sz="1400" dirty="0">
                 <a:solidFill>
                   <a:srgbClr val="1A1A1A"/>
                 </a:solidFill>
-                <a:latin typeface="Cambria" pitchFamily="34" charset="0"/>
-                <a:ea typeface="Cambria" pitchFamily="34" charset="-122"/>
-                <a:cs typeface="Cambria" pitchFamily="34" charset="-120"/>
-              </a:rPr>
-              <a:t>Two communities sit far apart in count-space. What exactly is far apart: the people, their topics, or the genre of writing? How would you tell?</a:t>
-            </a:r>
-            <a:endParaRPr lang="en-US" sz="1350" dirty="0"/>
-          </a:p>
-        </p:txBody>
-      </p:sp>
-      <p:sp>
-        <p:nvSpPr>
-          <p:cNvPr id="10" name="Shape 8"/>
-          <p:cNvSpPr/>
-          <p:nvPr/>
-        </p:nvSpPr>
-        <p:spPr>
-          <a:xfrm>
-            <a:off x="640080" y="4123944"/>
-            <a:ext cx="10881360" cy="1024128"/>
-          </a:xfrm>
-          <a:prstGeom prst="roundRect">
-            <a:avLst>
-              <a:gd name="adj" fmla="val 8929"/>
-            </a:avLst>
-          </a:prstGeom>
-          <a:solidFill>
-            <a:srgbClr val="F4EEE8"/>
-          </a:solidFill>
-          <a:ln/>
-        </p:spPr>
-      </p:sp>
-      <p:sp>
-        <p:nvSpPr>
-          <p:cNvPr id="11" name="Shape 9"/>
-          <p:cNvSpPr/>
-          <p:nvPr/>
-        </p:nvSpPr>
-        <p:spPr>
-          <a:xfrm>
-            <a:off x="914400" y="4398264"/>
-            <a:ext cx="292608" cy="292608"/>
-          </a:xfrm>
-          <a:prstGeom prst="ellipse">
-            <a:avLst/>
-          </a:prstGeom>
-          <a:solidFill>
-            <a:srgbClr val="7A3B2E"/>
-          </a:solidFill>
-          <a:ln/>
-        </p:spPr>
-      </p:sp>
-      <p:sp>
-        <p:nvSpPr>
-          <p:cNvPr id="12" name="Text 10"/>
-          <p:cNvSpPr/>
-          <p:nvPr/>
-        </p:nvSpPr>
-        <p:spPr>
-          <a:xfrm>
-            <a:off x="1417320" y="4187952"/>
-            <a:ext cx="9875520" cy="896112"/>
-          </a:xfrm>
-          <a:prstGeom prst="rect">
-            <a:avLst/>
-          </a:prstGeom>
-          <a:noFill/>
-          <a:ln/>
-        </p:spPr>
-        <p:txBody>
-          <a:bodyPr wrap="square" lIns="0" tIns="0" rIns="0" bIns="0" rtlCol="0" anchor="ctr"/>
-          <a:lstStyle/>
-          <a:p>
-            <a:pPr indent="0" marL="0">
-              <a:buNone/>
-            </a:pPr>
-            <a:r>
-              <a:rPr lang="en-US" sz="1350" i="1" dirty="0">
+                <a:latin typeface="Calibri" pitchFamily="34" charset="0"/>
+                <a:ea typeface="Calibri" pitchFamily="34" charset="-122"/>
+                <a:cs typeface="Calibri" pitchFamily="34" charset="-120"/>
+              </a:rPr>
+              <a:t>Evidence the composition story cannot explain. Not proof of sadness: AskReddit's users drifted, the proxy is 19 words, each point is a few hundred comments (the error bars are the bootstrap saying so).</a:t>
+            </a:r>
+            <a:endParaRPr lang="en-US" sz="1400" dirty="0"/>
+          </a:p>
+          <a:p>
+            <a:pPr marL="152400" indent="-152400">
+              <a:lnSpc>
+                <a:spcPct val="115000"/>
+              </a:lnSpc>
+              <a:spcAft>
+                <a:spcPts val="1000"/>
+              </a:spcAft>
+              <a:buSzPct val="100000"/>
+              <a:buChar char="•"/>
+            </a:pPr>
+            <a:r>
+              <a:rPr lang="en-US" sz="1400" dirty="0">
                 <a:solidFill>
                   <a:srgbClr val="1A1A1A"/>
                 </a:solidFill>
-                <a:latin typeface="Cambria" pitchFamily="34" charset="0"/>
-                <a:ea typeface="Cambria" pitchFamily="34" charset="-122"/>
-                <a:cs typeface="Cambria" pitchFamily="34" charset="-120"/>
-              </a:rPr>
-              <a:t>Your trend beat shuffled years. Is the finding TRUE? What is the difference between “not chance” and “what I said it means”?</a:t>
-            </a:r>
-            <a:endParaRPr lang="en-US" sz="1350" dirty="0"/>
-          </a:p>
-        </p:txBody>
-      </p:sp>
-      <p:sp>
-        <p:nvSpPr>
-          <p:cNvPr id="13" name="Shape 11"/>
-          <p:cNvSpPr/>
-          <p:nvPr/>
-        </p:nvSpPr>
-        <p:spPr>
-          <a:xfrm>
-            <a:off x="640080" y="5294376"/>
-            <a:ext cx="10881360" cy="1024128"/>
-          </a:xfrm>
-          <a:prstGeom prst="roundRect">
-            <a:avLst>
-              <a:gd name="adj" fmla="val 8929"/>
-            </a:avLst>
-          </a:prstGeom>
-          <a:solidFill>
-            <a:srgbClr val="F4EEE8"/>
-          </a:solidFill>
-          <a:ln/>
-        </p:spPr>
-      </p:sp>
-      <p:sp>
-        <p:nvSpPr>
-          <p:cNvPr id="14" name="Shape 12"/>
-          <p:cNvSpPr/>
-          <p:nvPr/>
-        </p:nvSpPr>
-        <p:spPr>
-          <a:xfrm>
-            <a:off x="914400" y="5568696"/>
-            <a:ext cx="292608" cy="292608"/>
-          </a:xfrm>
-          <a:prstGeom prst="ellipse">
-            <a:avLst/>
-          </a:prstGeom>
-          <a:solidFill>
-            <a:srgbClr val="B9852F"/>
-          </a:solidFill>
-          <a:ln/>
-        </p:spPr>
-      </p:sp>
-      <p:sp>
-        <p:nvSpPr>
-          <p:cNvPr id="15" name="Text 13"/>
-          <p:cNvSpPr/>
-          <p:nvPr/>
-        </p:nvSpPr>
-        <p:spPr>
-          <a:xfrm>
-            <a:off x="1417320" y="5358384"/>
-            <a:ext cx="9875520" cy="896112"/>
-          </a:xfrm>
-          <a:prstGeom prst="rect">
-            <a:avLst/>
-          </a:prstGeom>
-          <a:noFill/>
-          <a:ln/>
-        </p:spPr>
-        <p:txBody>
-          <a:bodyPr wrap="square" lIns="0" tIns="0" rIns="0" bIns="0" rtlCol="0" anchor="ctr"/>
-          <a:lstStyle/>
-          <a:p>
-            <a:pPr indent="0" marL="0">
-              <a:buNone/>
-            </a:pPr>
-            <a:r>
-              <a:rPr lang="en-US" sz="1350" i="1" dirty="0">
-                <a:solidFill>
-                  <a:srgbClr val="1A1A1A"/>
-                </a:solidFill>
-                <a:latin typeface="Cambria" pitchFamily="34" charset="0"/>
-                <a:ea typeface="Cambria" pitchFamily="34" charset="-122"/>
-                <a:cs typeface="Cambria" pitchFamily="34" charset="-120"/>
-              </a:rPr>
-              <a:t>The ratio climbed in books AND on Reddit. One truth measured twice, or two facts about two archives? What third corpus would decide?</a:t>
-            </a:r>
-            <a:endParaRPr lang="en-US" sz="1350" dirty="0"/>
+                <a:latin typeface="Calibri" pitchFamily="34" charset="0"/>
+                <a:ea typeface="Calibri" pitchFamily="34" charset="-122"/>
+                <a:cs typeface="Calibri" pitchFamily="34" charset="-120"/>
+              </a:rPr>
+              <a:t>What survives a second community, another word list, and bigger samples, you may say out loud.</a:t>
+            </a:r>
+            <a:endParaRPr lang="en-US" sz="1400" dirty="0"/>
           </a:p>
         </p:txBody>
       </p:sp>
@@ -5009,6 +4902,1287 @@
 <file path=ppt/slides/slide16.xml><?xml version="1.0" encoding="utf-8"?>
 <p:sld xmlns:a="http://schemas.openxmlformats.org/drawingml/2006/main" xmlns:r="http://schemas.openxmlformats.org/officeDocument/2006/relationships" xmlns:p="http://schemas.openxmlformats.org/presentationml/2006/main">
   <p:cSld name="Slide 16">
+    <p:bg>
+      <p:bgPr>
+        <a:solidFill>
+          <a:srgbClr val="FFFFFF"/>
+        </a:solidFill>
+      </p:bgPr>
+    </p:bg>
+    <p:spTree>
+      <p:nvGrpSpPr>
+        <p:cNvPr id="1" name=""/>
+        <p:cNvGrpSpPr/>
+        <p:nvPr/>
+      </p:nvGrpSpPr>
+      <p:grpSpPr>
+        <a:xfrm>
+          <a:off x="0" y="0"/>
+          <a:ext cx="0" cy="0"/>
+          <a:chOff x="0" y="0"/>
+          <a:chExt cx="0" cy="0"/>
+        </a:xfrm>
+      </p:grpSpPr>
+      <p:sp>
+        <p:nvSpPr>
+          <p:cNvPr id="2" name="Text 0"/>
+          <p:cNvSpPr/>
+          <p:nvPr/>
+        </p:nvSpPr>
+        <p:spPr>
+          <a:xfrm>
+            <a:off x="640080" y="502920"/>
+            <a:ext cx="10515600" cy="320040"/>
+          </a:xfrm>
+          <a:prstGeom prst="rect">
+            <a:avLst/>
+          </a:prstGeom>
+          <a:noFill/>
+          <a:ln/>
+        </p:spPr>
+        <p:txBody>
+          <a:bodyPr wrap="square" rtlCol="0" anchor="ctr"/>
+          <a:lstStyle/>
+          <a:p>
+            <a:pPr indent="0" marL="0">
+              <a:buNone/>
+            </a:pPr>
+            <a:r>
+              <a:rPr lang="en-US" sz="1300" b="1" spc="300" kern="0" dirty="0">
+                <a:solidFill>
+                  <a:srgbClr val="7A3B2E"/>
+                </a:solidFill>
+                <a:latin typeface="Calibri" pitchFamily="34" charset="0"/>
+                <a:ea typeface="Calibri" pitchFamily="34" charset="-122"/>
+                <a:cs typeface="Calibri" pitchFamily="34" charset="-120"/>
+              </a:rPr>
+              <a:t>THE CAPSTONE IDEA</a:t>
+            </a:r>
+            <a:endParaRPr lang="en-US" sz="1300" dirty="0"/>
+          </a:p>
+        </p:txBody>
+      </p:sp>
+      <p:sp>
+        <p:nvSpPr>
+          <p:cNvPr id="3" name="Text 1"/>
+          <p:cNvSpPr/>
+          <p:nvPr/>
+        </p:nvSpPr>
+        <p:spPr>
+          <a:xfrm>
+            <a:off x="640080" y="868680"/>
+            <a:ext cx="10972800" cy="777240"/>
+          </a:xfrm>
+          <a:prstGeom prst="rect">
+            <a:avLst/>
+          </a:prstGeom>
+          <a:noFill/>
+          <a:ln/>
+        </p:spPr>
+        <p:txBody>
+          <a:bodyPr wrap="square" rtlCol="0" anchor="t"/>
+          <a:lstStyle/>
+          <a:p>
+            <a:pPr indent="0" marL="0">
+              <a:buNone/>
+            </a:pPr>
+            <a:r>
+              <a:rPr lang="en-US" sz="3400" b="1" dirty="0">
+                <a:solidFill>
+                  <a:srgbClr val="1A1A1A"/>
+                </a:solidFill>
+                <a:latin typeface="Cambria" pitchFamily="34" charset="0"/>
+                <a:ea typeface="Cambria" pitchFamily="34" charset="-122"/>
+                <a:cs typeface="Cambria" pitchFamily="34" charset="-120"/>
+              </a:rPr>
+              <a:t>How do we prove anything with statistics?</a:t>
+            </a:r>
+            <a:endParaRPr lang="en-US" sz="3400" dirty="0"/>
+          </a:p>
+        </p:txBody>
+      </p:sp>
+      <p:sp>
+        <p:nvSpPr>
+          <p:cNvPr id="4" name="Text 2"/>
+          <p:cNvSpPr/>
+          <p:nvPr/>
+        </p:nvSpPr>
+        <p:spPr>
+          <a:xfrm>
+            <a:off x="640080" y="1737360"/>
+            <a:ext cx="10881360" cy="777240"/>
+          </a:xfrm>
+          <a:prstGeom prst="rect">
+            <a:avLst/>
+          </a:prstGeom>
+          <a:noFill/>
+          <a:ln/>
+        </p:spPr>
+        <p:txBody>
+          <a:bodyPr wrap="square" rtlCol="0" anchor="ctr"/>
+          <a:lstStyle/>
+          <a:p>
+            <a:pPr indent="0" marL="0">
+              <a:lnSpc>
+                <a:spcPct val="120000"/>
+              </a:lnSpc>
+              <a:buNone/>
+            </a:pPr>
+            <a:r>
+              <a:rPr lang="en-US" sz="1700" i="1" dirty="0">
+                <a:solidFill>
+                  <a:srgbClr val="1A1A1A"/>
+                </a:solidFill>
+                <a:latin typeface="Cambria" pitchFamily="34" charset="0"/>
+                <a:ea typeface="Cambria" pitchFamily="34" charset="-122"/>
+                <a:cs typeface="Cambria" pitchFamily="34" charset="-120"/>
+              </a:rPr>
+              <a:t>We don't. Statistics never proves a claim; it eliminates rivals. A finding is the claim left standing after every challenger you and your critics could name has had its turn.</a:t>
+            </a:r>
+            <a:endParaRPr lang="en-US" sz="1700" dirty="0"/>
+          </a:p>
+        </p:txBody>
+      </p:sp>
+      <p:sp>
+        <p:nvSpPr>
+          <p:cNvPr id="5" name="Shape 3"/>
+          <p:cNvSpPr/>
+          <p:nvPr/>
+        </p:nvSpPr>
+        <p:spPr>
+          <a:xfrm>
+            <a:off x="640080" y="2697480"/>
+            <a:ext cx="10881360" cy="987552"/>
+          </a:xfrm>
+          <a:prstGeom prst="roundRect">
+            <a:avLst>
+              <a:gd name="adj" fmla="val 9259"/>
+            </a:avLst>
+          </a:prstGeom>
+          <a:solidFill>
+            <a:srgbClr val="F4EEE8"/>
+          </a:solidFill>
+          <a:ln/>
+        </p:spPr>
+      </p:sp>
+      <p:sp>
+        <p:nvSpPr>
+          <p:cNvPr id="6" name="Text 4"/>
+          <p:cNvSpPr/>
+          <p:nvPr/>
+        </p:nvSpPr>
+        <p:spPr>
+          <a:xfrm>
+            <a:off x="960120" y="2761488"/>
+            <a:ext cx="2834640" cy="868680"/>
+          </a:xfrm>
+          <a:prstGeom prst="rect">
+            <a:avLst/>
+          </a:prstGeom>
+          <a:noFill/>
+          <a:ln/>
+        </p:spPr>
+        <p:txBody>
+          <a:bodyPr wrap="square" lIns="0" tIns="0" rIns="0" bIns="0" rtlCol="0" anchor="ctr"/>
+          <a:lstStyle/>
+          <a:p>
+            <a:pPr indent="0" marL="0">
+              <a:buNone/>
+            </a:pPr>
+            <a:r>
+              <a:rPr lang="en-US" sz="1500" b="1" dirty="0">
+                <a:solidFill>
+                  <a:srgbClr val="3F6F5F"/>
+                </a:solidFill>
+                <a:latin typeface="Cambria" pitchFamily="34" charset="0"/>
+                <a:ea typeface="Cambria" pitchFamily="34" charset="-122"/>
+                <a:cs typeface="Cambria" pitchFamily="34" charset="-120"/>
+              </a:rPr>
+              <a:t>Rival 1: chance</a:t>
+            </a:r>
+            <a:endParaRPr lang="en-US" sz="1500" dirty="0"/>
+          </a:p>
+        </p:txBody>
+      </p:sp>
+      <p:sp>
+        <p:nvSpPr>
+          <p:cNvPr id="7" name="Text 5"/>
+          <p:cNvSpPr/>
+          <p:nvPr/>
+        </p:nvSpPr>
+        <p:spPr>
+          <a:xfrm>
+            <a:off x="3931920" y="2761488"/>
+            <a:ext cx="7315200" cy="868680"/>
+          </a:xfrm>
+          <a:prstGeom prst="rect">
+            <a:avLst/>
+          </a:prstGeom>
+          <a:noFill/>
+          <a:ln/>
+        </p:spPr>
+        <p:txBody>
+          <a:bodyPr wrap="square" lIns="0" tIns="0" rIns="0" bIns="0" rtlCol="0" anchor="ctr"/>
+          <a:lstStyle/>
+          <a:p>
+            <a:pPr indent="0" marL="0">
+              <a:buNone/>
+            </a:pPr>
+            <a:r>
+              <a:rPr lang="en-US" sz="1200" dirty="0">
+                <a:solidFill>
+                  <a:srgbClr val="1A1A1A"/>
+                </a:solidFill>
+                <a:latin typeface="Calibri" pitchFamily="34" charset="0"/>
+                <a:ea typeface="Calibri" pitchFamily="34" charset="-122"/>
+                <a:cs typeface="Calibri" pitchFamily="34" charset="-120"/>
+              </a:rPr>
+              <a:t>“Randomly dealt data would show this too.” Answer: the shuffle test. Break the structure 1,000 times; if chance rarely draws your gap, this rival is out. That is all a p-value ever says.</a:t>
+            </a:r>
+            <a:endParaRPr lang="en-US" sz="1200" dirty="0"/>
+          </a:p>
+        </p:txBody>
+      </p:sp>
+      <p:sp>
+        <p:nvSpPr>
+          <p:cNvPr id="8" name="Shape 6"/>
+          <p:cNvSpPr/>
+          <p:nvPr/>
+        </p:nvSpPr>
+        <p:spPr>
+          <a:xfrm>
+            <a:off x="640080" y="3840480"/>
+            <a:ext cx="10881360" cy="987552"/>
+          </a:xfrm>
+          <a:prstGeom prst="roundRect">
+            <a:avLst>
+              <a:gd name="adj" fmla="val 9259"/>
+            </a:avLst>
+          </a:prstGeom>
+          <a:solidFill>
+            <a:srgbClr val="F4EEE8"/>
+          </a:solidFill>
+          <a:ln/>
+        </p:spPr>
+      </p:sp>
+      <p:sp>
+        <p:nvSpPr>
+          <p:cNvPr id="9" name="Text 7"/>
+          <p:cNvSpPr/>
+          <p:nvPr/>
+        </p:nvSpPr>
+        <p:spPr>
+          <a:xfrm>
+            <a:off x="960120" y="3904488"/>
+            <a:ext cx="2834640" cy="868680"/>
+          </a:xfrm>
+          <a:prstGeom prst="rect">
+            <a:avLst/>
+          </a:prstGeom>
+          <a:noFill/>
+          <a:ln/>
+        </p:spPr>
+        <p:txBody>
+          <a:bodyPr wrap="square" lIns="0" tIns="0" rIns="0" bIns="0" rtlCol="0" anchor="ctr"/>
+          <a:lstStyle/>
+          <a:p>
+            <a:pPr indent="0" marL="0">
+              <a:buNone/>
+            </a:pPr>
+            <a:r>
+              <a:rPr lang="en-US" sz="1500" b="1" dirty="0">
+                <a:solidFill>
+                  <a:srgbClr val="B9852F"/>
+                </a:solidFill>
+                <a:latin typeface="Cambria" pitchFamily="34" charset="0"/>
+                <a:ea typeface="Cambria" pitchFamily="34" charset="-122"/>
+                <a:cs typeface="Cambria" pitchFamily="34" charset="-120"/>
+              </a:rPr>
+              <a:t>Rival 2: something else did it</a:t>
+            </a:r>
+            <a:endParaRPr lang="en-US" sz="1500" dirty="0"/>
+          </a:p>
+        </p:txBody>
+      </p:sp>
+      <p:sp>
+        <p:nvSpPr>
+          <p:cNvPr id="10" name="Text 8"/>
+          <p:cNvSpPr/>
+          <p:nvPr/>
+        </p:nvSpPr>
+        <p:spPr>
+          <a:xfrm>
+            <a:off x="3931920" y="3904488"/>
+            <a:ext cx="7315200" cy="868680"/>
+          </a:xfrm>
+          <a:prstGeom prst="rect">
+            <a:avLst/>
+          </a:prstGeom>
+          <a:noFill/>
+          <a:ln/>
+        </p:spPr>
+        <p:txBody>
+          <a:bodyPr wrap="square" lIns="0" tIns="0" rIns="0" bIns="0" rtlCol="0" anchor="ctr"/>
+          <a:lstStyle/>
+          <a:p>
+            <a:pPr indent="0" marL="0">
+              <a:buNone/>
+            </a:pPr>
+            <a:r>
+              <a:rPr lang="en-US" sz="1200" dirty="0">
+                <a:solidFill>
+                  <a:srgbClr val="1A1A1A"/>
+                </a:solidFill>
+                <a:latin typeface="Calibri" pitchFamily="34" charset="0"/>
+                <a:ea typeface="Calibri" pitchFamily="34" charset="-122"/>
+                <a:cs typeface="Calibri" pitchFamily="34" charset="-120"/>
+              </a:rPr>
+              <a:t>“The corpus changed under you” (Schmidt). Answer: design, not statistics. Hold the community fixed; remove the fiction; re-run without the suspect slice. Each control retires one rival by name.</a:t>
+            </a:r>
+            <a:endParaRPr lang="en-US" sz="1200" dirty="0"/>
+          </a:p>
+        </p:txBody>
+      </p:sp>
+      <p:sp>
+        <p:nvSpPr>
+          <p:cNvPr id="11" name="Shape 9"/>
+          <p:cNvSpPr/>
+          <p:nvPr/>
+        </p:nvSpPr>
+        <p:spPr>
+          <a:xfrm>
+            <a:off x="640080" y="4983480"/>
+            <a:ext cx="10881360" cy="987552"/>
+          </a:xfrm>
+          <a:prstGeom prst="roundRect">
+            <a:avLst>
+              <a:gd name="adj" fmla="val 9259"/>
+            </a:avLst>
+          </a:prstGeom>
+          <a:solidFill>
+            <a:srgbClr val="F4EEE8"/>
+          </a:solidFill>
+          <a:ln/>
+        </p:spPr>
+      </p:sp>
+      <p:sp>
+        <p:nvSpPr>
+          <p:cNvPr id="12" name="Text 10"/>
+          <p:cNvSpPr/>
+          <p:nvPr/>
+        </p:nvSpPr>
+        <p:spPr>
+          <a:xfrm>
+            <a:off x="960120" y="5047488"/>
+            <a:ext cx="2834640" cy="868680"/>
+          </a:xfrm>
+          <a:prstGeom prst="rect">
+            <a:avLst/>
+          </a:prstGeom>
+          <a:noFill/>
+          <a:ln/>
+        </p:spPr>
+        <p:txBody>
+          <a:bodyPr wrap="square" lIns="0" tIns="0" rIns="0" bIns="0" rtlCol="0" anchor="ctr"/>
+          <a:lstStyle/>
+          <a:p>
+            <a:pPr indent="0" marL="0">
+              <a:buNone/>
+            </a:pPr>
+            <a:r>
+              <a:rPr lang="en-US" sz="1500" b="1" dirty="0">
+                <a:solidFill>
+                  <a:srgbClr val="2E5F8A"/>
+                </a:solidFill>
+                <a:latin typeface="Cambria" pitchFamily="34" charset="0"/>
+                <a:ea typeface="Cambria" pitchFamily="34" charset="-122"/>
+                <a:cs typeface="Cambria" pitchFamily="34" charset="-120"/>
+              </a:rPr>
+              <a:t>Rival 3: true but trivial, or true but local</a:t>
+            </a:r>
+            <a:endParaRPr lang="en-US" sz="1500" dirty="0"/>
+          </a:p>
+        </p:txBody>
+      </p:sp>
+      <p:sp>
+        <p:nvSpPr>
+          <p:cNvPr id="13" name="Text 11"/>
+          <p:cNvSpPr/>
+          <p:nvPr/>
+        </p:nvSpPr>
+        <p:spPr>
+          <a:xfrm>
+            <a:off x="3931920" y="5047488"/>
+            <a:ext cx="7315200" cy="868680"/>
+          </a:xfrm>
+          <a:prstGeom prst="rect">
+            <a:avLst/>
+          </a:prstGeom>
+          <a:noFill/>
+          <a:ln/>
+        </p:spPr>
+        <p:txBody>
+          <a:bodyPr wrap="square" lIns="0" tIns="0" rIns="0" bIns="0" rtlCol="0" anchor="ctr"/>
+          <a:lstStyle/>
+          <a:p>
+            <a:pPr indent="0" marL="0">
+              <a:buNone/>
+            </a:pPr>
+            <a:r>
+              <a:rPr lang="en-US" sz="1200" dirty="0">
+                <a:solidFill>
+                  <a:srgbClr val="1A1A1A"/>
+                </a:solidFill>
+                <a:latin typeface="Calibri" pitchFamily="34" charset="0"/>
+                <a:ea typeface="Calibri" pitchFamily="34" charset="-122"/>
+                <a:cs typeface="Calibri" pitchFamily="34" charset="-120"/>
+              </a:rPr>
+              <a:t>Answer: the bootstrap's interval for size, and scope stated out loud: announced-in-the-Times brides, one subreddit, 19 proxy words. A claim without its scope is not yet a claim.</a:t>
+            </a:r>
+            <a:endParaRPr lang="en-US" sz="1200" dirty="0"/>
+          </a:p>
+        </p:txBody>
+      </p:sp>
+      <p:sp>
+        <p:nvSpPr>
+          <p:cNvPr id="14" name="Text 12"/>
+          <p:cNvSpPr/>
+          <p:nvPr/>
+        </p:nvSpPr>
+        <p:spPr>
+          <a:xfrm>
+            <a:off x="640080" y="6172200"/>
+            <a:ext cx="10881360" cy="594360"/>
+          </a:xfrm>
+          <a:prstGeom prst="rect">
+            <a:avLst/>
+          </a:prstGeom>
+          <a:noFill/>
+          <a:ln/>
+        </p:spPr>
+        <p:txBody>
+          <a:bodyPr wrap="square" rtlCol="0" anchor="ctr"/>
+          <a:lstStyle/>
+          <a:p>
+            <a:pPr indent="0" marL="0">
+              <a:lnSpc>
+                <a:spcPct val="115000"/>
+              </a:lnSpc>
+              <a:buNone/>
+            </a:pPr>
+            <a:r>
+              <a:rPr lang="en-US" sz="1250" i="1" dirty="0">
+                <a:solidFill>
+                  <a:srgbClr val="6B6B63"/>
+                </a:solidFill>
+                <a:latin typeface="Calibri" pitchFamily="34" charset="0"/>
+                <a:ea typeface="Calibri" pitchFamily="34" charset="-122"/>
+                <a:cs typeface="Calibri" pitchFamily="34" charset="-120"/>
+              </a:rPr>
+              <a:t>So the argument's shape is: named claim → named rivals → a test or a design that retires each → the size, with its interval → the scope. Bollen argued this way; Schmidt answered this way; you replicated this way. Truth, here, is what survives.</a:t>
+            </a:r>
+            <a:endParaRPr lang="en-US" sz="1250" dirty="0"/>
+          </a:p>
+        </p:txBody>
+      </p:sp>
+    </p:spTree>
+  </p:cSld>
+  <p:clrMapOvr>
+    <a:masterClrMapping/>
+  </p:clrMapOvr>
+</p:sld>
+</file>
+
+<file path=ppt/slides/slide17.xml><?xml version="1.0" encoding="utf-8"?>
+<p:sld xmlns:a="http://schemas.openxmlformats.org/drawingml/2006/main" xmlns:r="http://schemas.openxmlformats.org/officeDocument/2006/relationships" xmlns:p="http://schemas.openxmlformats.org/presentationml/2006/main">
+  <p:cSld name="Slide 17">
+    <p:bg>
+      <p:bgPr>
+        <a:solidFill>
+          <a:srgbClr val="FFFFFF"/>
+        </a:solidFill>
+      </p:bgPr>
+    </p:bg>
+    <p:spTree>
+      <p:nvGrpSpPr>
+        <p:cNvPr id="1" name=""/>
+        <p:cNvGrpSpPr/>
+        <p:nvPr/>
+      </p:nvGrpSpPr>
+      <p:grpSpPr>
+        <a:xfrm>
+          <a:off x="0" y="0"/>
+          <a:ext cx="0" cy="0"/>
+          <a:chOff x="0" y="0"/>
+          <a:chExt cx="0" cy="0"/>
+        </a:xfrm>
+      </p:grpSpPr>
+      <p:sp>
+        <p:nvSpPr>
+          <p:cNvPr id="2" name="Text 0"/>
+          <p:cNvSpPr/>
+          <p:nvPr/>
+        </p:nvSpPr>
+        <p:spPr>
+          <a:xfrm>
+            <a:off x="640080" y="502920"/>
+            <a:ext cx="10515600" cy="320040"/>
+          </a:xfrm>
+          <a:prstGeom prst="rect">
+            <a:avLst/>
+          </a:prstGeom>
+          <a:noFill/>
+          <a:ln/>
+        </p:spPr>
+        <p:txBody>
+          <a:bodyPr wrap="square" rtlCol="0" anchor="ctr"/>
+          <a:lstStyle/>
+          <a:p>
+            <a:pPr indent="0" marL="0">
+              <a:buNone/>
+            </a:pPr>
+            <a:r>
+              <a:rPr lang="en-US" sz="1300" b="1" spc="300" kern="0" dirty="0">
+                <a:solidFill>
+                  <a:srgbClr val="7A3B2E"/>
+                </a:solidFill>
+                <a:latin typeface="Calibri" pitchFamily="34" charset="0"/>
+                <a:ea typeface="Calibri" pitchFamily="34" charset="-122"/>
+                <a:cs typeface="Calibri" pitchFamily="34" charset="-120"/>
+              </a:rPr>
+              <a:t>DISCUSSION · COUNTING</a:t>
+            </a:r>
+            <a:endParaRPr lang="en-US" sz="1300" dirty="0"/>
+          </a:p>
+        </p:txBody>
+      </p:sp>
+      <p:sp>
+        <p:nvSpPr>
+          <p:cNvPr id="3" name="Text 1"/>
+          <p:cNvSpPr/>
+          <p:nvPr/>
+        </p:nvSpPr>
+        <p:spPr>
+          <a:xfrm>
+            <a:off x="640080" y="868680"/>
+            <a:ext cx="10972800" cy="777240"/>
+          </a:xfrm>
+          <a:prstGeom prst="rect">
+            <a:avLst/>
+          </a:prstGeom>
+          <a:noFill/>
+          <a:ln/>
+        </p:spPr>
+        <p:txBody>
+          <a:bodyPr wrap="square" rtlCol="0" anchor="t"/>
+          <a:lstStyle/>
+          <a:p>
+            <a:pPr indent="0" marL="0">
+              <a:buNone/>
+            </a:pPr>
+            <a:r>
+              <a:rPr lang="en-US" sz="3400" b="1" dirty="0">
+                <a:solidFill>
+                  <a:srgbClr val="1A1A1A"/>
+                </a:solidFill>
+                <a:latin typeface="Cambria" pitchFamily="34" charset="0"/>
+                <a:ea typeface="Cambria" pitchFamily="34" charset="-122"/>
+                <a:cs typeface="Cambria" pitchFamily="34" charset="-120"/>
+              </a:rPr>
+              <a:t>What did the count actually measure?</a:t>
+            </a:r>
+            <a:endParaRPr lang="en-US" sz="3400" dirty="0"/>
+          </a:p>
+        </p:txBody>
+      </p:sp>
+      <p:sp>
+        <p:nvSpPr>
+          <p:cNvPr id="4" name="Shape 2"/>
+          <p:cNvSpPr/>
+          <p:nvPr/>
+        </p:nvSpPr>
+        <p:spPr>
+          <a:xfrm>
+            <a:off x="640080" y="2011680"/>
+            <a:ext cx="10881360" cy="1188720"/>
+          </a:xfrm>
+          <a:prstGeom prst="roundRect">
+            <a:avLst>
+              <a:gd name="adj" fmla="val 7692"/>
+            </a:avLst>
+          </a:prstGeom>
+          <a:solidFill>
+            <a:srgbClr val="F4EEE8"/>
+          </a:solidFill>
+          <a:ln/>
+        </p:spPr>
+      </p:sp>
+      <p:sp>
+        <p:nvSpPr>
+          <p:cNvPr id="5" name="Shape 3"/>
+          <p:cNvSpPr/>
+          <p:nvPr/>
+        </p:nvSpPr>
+        <p:spPr>
+          <a:xfrm>
+            <a:off x="914400" y="2286000"/>
+            <a:ext cx="320040" cy="320040"/>
+          </a:xfrm>
+          <a:prstGeom prst="ellipse">
+            <a:avLst/>
+          </a:prstGeom>
+          <a:solidFill>
+            <a:srgbClr val="7A3B2E"/>
+          </a:solidFill>
+          <a:ln/>
+        </p:spPr>
+      </p:sp>
+      <p:sp>
+        <p:nvSpPr>
+          <p:cNvPr id="6" name="Text 4"/>
+          <p:cNvSpPr/>
+          <p:nvPr/>
+        </p:nvSpPr>
+        <p:spPr>
+          <a:xfrm>
+            <a:off x="1463040" y="2103120"/>
+            <a:ext cx="9784080" cy="1051560"/>
+          </a:xfrm>
+          <a:prstGeom prst="rect">
+            <a:avLst/>
+          </a:prstGeom>
+          <a:noFill/>
+          <a:ln/>
+        </p:spPr>
+        <p:txBody>
+          <a:bodyPr wrap="square" lIns="0" tIns="0" rIns="0" bIns="0" rtlCol="0" anchor="ctr"/>
+          <a:lstStyle/>
+          <a:p>
+            <a:pPr indent="0" marL="0">
+              <a:buNone/>
+            </a:pPr>
+            <a:r>
+              <a:rPr lang="en-US" sz="1500" i="1" dirty="0">
+                <a:solidFill>
+                  <a:srgbClr val="1A1A1A"/>
+                </a:solidFill>
+                <a:latin typeface="Cambria" pitchFamily="34" charset="0"/>
+                <a:ea typeface="Cambria" pitchFamily="34" charset="-122"/>
+                <a:cs typeface="Cambria" pitchFamily="34" charset="-120"/>
+              </a:rPr>
+              <a:t>Absolutist words rose. List every explanation: feelings, phones, age of users, comment length, moderation. Which could you test with today's tools?</a:t>
+            </a:r>
+            <a:endParaRPr lang="en-US" sz="1500" dirty="0"/>
+          </a:p>
+        </p:txBody>
+      </p:sp>
+      <p:sp>
+        <p:nvSpPr>
+          <p:cNvPr id="7" name="Shape 5"/>
+          <p:cNvSpPr/>
+          <p:nvPr/>
+        </p:nvSpPr>
+        <p:spPr>
+          <a:xfrm>
+            <a:off x="640080" y="3383280"/>
+            <a:ext cx="10881360" cy="1188720"/>
+          </a:xfrm>
+          <a:prstGeom prst="roundRect">
+            <a:avLst>
+              <a:gd name="adj" fmla="val 7692"/>
+            </a:avLst>
+          </a:prstGeom>
+          <a:solidFill>
+            <a:srgbClr val="F4EEE8"/>
+          </a:solidFill>
+          <a:ln/>
+        </p:spPr>
+      </p:sp>
+      <p:sp>
+        <p:nvSpPr>
+          <p:cNvPr id="8" name="Shape 6"/>
+          <p:cNvSpPr/>
+          <p:nvPr/>
+        </p:nvSpPr>
+        <p:spPr>
+          <a:xfrm>
+            <a:off x="914400" y="3657600"/>
+            <a:ext cx="320040" cy="320040"/>
+          </a:xfrm>
+          <a:prstGeom prst="ellipse">
+            <a:avLst/>
+          </a:prstGeom>
+          <a:solidFill>
+            <a:srgbClr val="B9852F"/>
+          </a:solidFill>
+          <a:ln/>
+        </p:spPr>
+      </p:sp>
+      <p:sp>
+        <p:nvSpPr>
+          <p:cNvPr id="9" name="Text 7"/>
+          <p:cNvSpPr/>
+          <p:nvPr/>
+        </p:nvSpPr>
+        <p:spPr>
+          <a:xfrm>
+            <a:off x="1463040" y="3474720"/>
+            <a:ext cx="9784080" cy="1051560"/>
+          </a:xfrm>
+          <a:prstGeom prst="rect">
+            <a:avLst/>
+          </a:prstGeom>
+          <a:noFill/>
+          <a:ln/>
+        </p:spPr>
+        <p:txBody>
+          <a:bodyPr wrap="square" lIns="0" tIns="0" rIns="0" bIns="0" rtlCol="0" anchor="ctr"/>
+          <a:lstStyle/>
+          <a:p>
+            <a:pPr indent="0" marL="0">
+              <a:buNone/>
+            </a:pPr>
+            <a:r>
+              <a:rPr lang="en-US" sz="1500" i="1" dirty="0">
+                <a:solidFill>
+                  <a:srgbClr val="1A1A1A"/>
+                </a:solidFill>
+                <a:latin typeface="Cambria" pitchFamily="34" charset="0"/>
+                <a:ea typeface="Cambria" pitchFamily="34" charset="-122"/>
+                <a:cs typeface="Cambria" pitchFamily="34" charset="-120"/>
+              </a:rPr>
+              <a:t>Daniels ranked rappers by unique words; Aesop Rock wins. What is that number a measurement OF: skill, genre, era, or the denominator?</a:t>
+            </a:r>
+            <a:endParaRPr lang="en-US" sz="1500" dirty="0"/>
+          </a:p>
+        </p:txBody>
+      </p:sp>
+      <p:sp>
+        <p:nvSpPr>
+          <p:cNvPr id="10" name="Shape 8"/>
+          <p:cNvSpPr/>
+          <p:nvPr/>
+        </p:nvSpPr>
+        <p:spPr>
+          <a:xfrm>
+            <a:off x="640080" y="4754880"/>
+            <a:ext cx="10881360" cy="1188720"/>
+          </a:xfrm>
+          <a:prstGeom prst="roundRect">
+            <a:avLst>
+              <a:gd name="adj" fmla="val 7692"/>
+            </a:avLst>
+          </a:prstGeom>
+          <a:solidFill>
+            <a:srgbClr val="F4EEE8"/>
+          </a:solidFill>
+          <a:ln/>
+        </p:spPr>
+      </p:sp>
+      <p:sp>
+        <p:nvSpPr>
+          <p:cNvPr id="11" name="Shape 9"/>
+          <p:cNvSpPr/>
+          <p:nvPr/>
+        </p:nvSpPr>
+        <p:spPr>
+          <a:xfrm>
+            <a:off x="914400" y="5029200"/>
+            <a:ext cx="320040" cy="320040"/>
+          </a:xfrm>
+          <a:prstGeom prst="ellipse">
+            <a:avLst/>
+          </a:prstGeom>
+          <a:solidFill>
+            <a:srgbClr val="3F6F5F"/>
+          </a:solidFill>
+          <a:ln/>
+        </p:spPr>
+      </p:sp>
+      <p:sp>
+        <p:nvSpPr>
+          <p:cNvPr id="12" name="Text 10"/>
+          <p:cNvSpPr/>
+          <p:nvPr/>
+        </p:nvSpPr>
+        <p:spPr>
+          <a:xfrm>
+            <a:off x="1463040" y="4846320"/>
+            <a:ext cx="9784080" cy="1051560"/>
+          </a:xfrm>
+          <a:prstGeom prst="rect">
+            <a:avLst/>
+          </a:prstGeom>
+          <a:noFill/>
+          <a:ln/>
+        </p:spPr>
+        <p:txBody>
+          <a:bodyPr wrap="square" lIns="0" tIns="0" rIns="0" bIns="0" rtlCol="0" anchor="ctr"/>
+          <a:lstStyle/>
+          <a:p>
+            <a:pPr indent="0" marL="0">
+              <a:buNone/>
+            </a:pPr>
+            <a:r>
+              <a:rPr lang="en-US" sz="1500" i="1" dirty="0">
+                <a:solidFill>
+                  <a:srgbClr val="1A1A1A"/>
+                </a:solidFill>
+                <a:latin typeface="Cambria" pitchFamily="34" charset="0"/>
+                <a:ea typeface="Cambria" pitchFamily="34" charset="-122"/>
+                <a:cs typeface="Cambria" pitchFamily="34" charset="-120"/>
+              </a:rPr>
+              <a:t>When is a zero a fact, and when is it a small sample? (Recall: “money” appeared 0 times in one gardening pull.)</a:t>
+            </a:r>
+            <a:endParaRPr lang="en-US" sz="1500" dirty="0"/>
+          </a:p>
+        </p:txBody>
+      </p:sp>
+    </p:spTree>
+  </p:cSld>
+  <p:clrMapOvr>
+    <a:masterClrMapping/>
+  </p:clrMapOvr>
+</p:sld>
+</file>
+
+<file path=ppt/slides/slide18.xml><?xml version="1.0" encoding="utf-8"?>
+<p:sld xmlns:a="http://schemas.openxmlformats.org/drawingml/2006/main" xmlns:r="http://schemas.openxmlformats.org/officeDocument/2006/relationships" xmlns:p="http://schemas.openxmlformats.org/presentationml/2006/main">
+  <p:cSld name="Slide 18">
+    <p:bg>
+      <p:bgPr>
+        <a:solidFill>
+          <a:srgbClr val="FFFFFF"/>
+        </a:solidFill>
+      </p:bgPr>
+    </p:bg>
+    <p:spTree>
+      <p:nvGrpSpPr>
+        <p:cNvPr id="1" name=""/>
+        <p:cNvGrpSpPr/>
+        <p:nvPr/>
+      </p:nvGrpSpPr>
+      <p:grpSpPr>
+        <a:xfrm>
+          <a:off x="0" y="0"/>
+          <a:ext cx="0" cy="0"/>
+          <a:chOff x="0" y="0"/>
+          <a:chExt cx="0" cy="0"/>
+        </a:xfrm>
+      </p:grpSpPr>
+      <p:sp>
+        <p:nvSpPr>
+          <p:cNvPr id="2" name="Text 0"/>
+          <p:cNvSpPr/>
+          <p:nvPr/>
+        </p:nvSpPr>
+        <p:spPr>
+          <a:xfrm>
+            <a:off x="640080" y="502920"/>
+            <a:ext cx="10515600" cy="320040"/>
+          </a:xfrm>
+          <a:prstGeom prst="rect">
+            <a:avLst/>
+          </a:prstGeom>
+          <a:noFill/>
+          <a:ln/>
+        </p:spPr>
+        <p:txBody>
+          <a:bodyPr wrap="square" rtlCol="0" anchor="ctr"/>
+          <a:lstStyle/>
+          <a:p>
+            <a:pPr indent="0" marL="0">
+              <a:buNone/>
+            </a:pPr>
+            <a:r>
+              <a:rPr lang="en-US" sz="1300" b="1" spc="300" kern="0" dirty="0">
+                <a:solidFill>
+                  <a:srgbClr val="2E5F8A"/>
+                </a:solidFill>
+                <a:latin typeface="Calibri" pitchFamily="34" charset="0"/>
+                <a:ea typeface="Calibri" pitchFamily="34" charset="-122"/>
+                <a:cs typeface="Calibri" pitchFamily="34" charset="-120"/>
+              </a:rPr>
+              <a:t>DISCUSSION · VECTORS AND TRUTH</a:t>
+            </a:r>
+            <a:endParaRPr lang="en-US" sz="1300" dirty="0"/>
+          </a:p>
+        </p:txBody>
+      </p:sp>
+      <p:sp>
+        <p:nvSpPr>
+          <p:cNvPr id="3" name="Text 1"/>
+          <p:cNvSpPr/>
+          <p:nvPr/>
+        </p:nvSpPr>
+        <p:spPr>
+          <a:xfrm>
+            <a:off x="640080" y="868680"/>
+            <a:ext cx="10972800" cy="777240"/>
+          </a:xfrm>
+          <a:prstGeom prst="rect">
+            <a:avLst/>
+          </a:prstGeom>
+          <a:noFill/>
+          <a:ln/>
+        </p:spPr>
+        <p:txBody>
+          <a:bodyPr wrap="square" rtlCol="0" anchor="t"/>
+          <a:lstStyle/>
+          <a:p>
+            <a:pPr indent="0" marL="0">
+              <a:buNone/>
+            </a:pPr>
+            <a:r>
+              <a:rPr lang="en-US" sz="3400" b="1" dirty="0">
+                <a:solidFill>
+                  <a:srgbClr val="1A1A1A"/>
+                </a:solidFill>
+                <a:latin typeface="Cambria" pitchFamily="34" charset="0"/>
+                <a:ea typeface="Cambria" pitchFamily="34" charset="-122"/>
+                <a:cs typeface="Cambria" pitchFamily="34" charset="-120"/>
+              </a:rPr>
+              <a:t>When numbers stand in for meaning</a:t>
+            </a:r>
+            <a:endParaRPr lang="en-US" sz="3400" dirty="0"/>
+          </a:p>
+        </p:txBody>
+      </p:sp>
+      <p:sp>
+        <p:nvSpPr>
+          <p:cNvPr id="4" name="Shape 2"/>
+          <p:cNvSpPr/>
+          <p:nvPr/>
+        </p:nvSpPr>
+        <p:spPr>
+          <a:xfrm>
+            <a:off x="640080" y="1783080"/>
+            <a:ext cx="10881360" cy="987552"/>
+          </a:xfrm>
+          <a:prstGeom prst="roundRect">
+            <a:avLst>
+              <a:gd name="adj" fmla="val 9259"/>
+            </a:avLst>
+          </a:prstGeom>
+          <a:solidFill>
+            <a:srgbClr val="F4EEE8"/>
+          </a:solidFill>
+          <a:ln/>
+        </p:spPr>
+      </p:sp>
+      <p:sp>
+        <p:nvSpPr>
+          <p:cNvPr id="5" name="Shape 3"/>
+          <p:cNvSpPr/>
+          <p:nvPr/>
+        </p:nvSpPr>
+        <p:spPr>
+          <a:xfrm>
+            <a:off x="914400" y="2057400"/>
+            <a:ext cx="320040" cy="320040"/>
+          </a:xfrm>
+          <a:prstGeom prst="ellipse">
+            <a:avLst/>
+          </a:prstGeom>
+          <a:solidFill>
+            <a:srgbClr val="2E5F8A"/>
+          </a:solidFill>
+          <a:ln/>
+        </p:spPr>
+      </p:sp>
+      <p:sp>
+        <p:nvSpPr>
+          <p:cNvPr id="6" name="Text 4"/>
+          <p:cNvSpPr/>
+          <p:nvPr/>
+        </p:nvSpPr>
+        <p:spPr>
+          <a:xfrm>
+            <a:off x="1463040" y="1874520"/>
+            <a:ext cx="9784080" cy="850392"/>
+          </a:xfrm>
+          <a:prstGeom prst="rect">
+            <a:avLst/>
+          </a:prstGeom>
+          <a:noFill/>
+          <a:ln/>
+        </p:spPr>
+        <p:txBody>
+          <a:bodyPr wrap="square" lIns="0" tIns="0" rIns="0" bIns="0" rtlCol="0" anchor="ctr"/>
+          <a:lstStyle/>
+          <a:p>
+            <a:pPr indent="0" marL="0">
+              <a:buNone/>
+            </a:pPr>
+            <a:r>
+              <a:rPr lang="en-US" sz="1350" i="1" dirty="0">
+                <a:solidFill>
+                  <a:srgbClr val="1A1A1A"/>
+                </a:solidFill>
+                <a:latin typeface="Cambria" pitchFamily="34" charset="0"/>
+                <a:ea typeface="Cambria" pitchFamily="34" charset="-122"/>
+                <a:cs typeface="Cambria" pitchFamily="34" charset="-120"/>
+              </a:rPr>
+              <a:t>A comment became a row of numbers, a community a cloud of points. What survived the translation, and what did not? One example of each.</a:t>
+            </a:r>
+            <a:endParaRPr lang="en-US" sz="1350" dirty="0"/>
+          </a:p>
+        </p:txBody>
+      </p:sp>
+      <p:sp>
+        <p:nvSpPr>
+          <p:cNvPr id="7" name="Shape 5"/>
+          <p:cNvSpPr/>
+          <p:nvPr/>
+        </p:nvSpPr>
+        <p:spPr>
+          <a:xfrm>
+            <a:off x="640080" y="2953512"/>
+            <a:ext cx="10881360" cy="987552"/>
+          </a:xfrm>
+          <a:prstGeom prst="roundRect">
+            <a:avLst>
+              <a:gd name="adj" fmla="val 9259"/>
+            </a:avLst>
+          </a:prstGeom>
+          <a:solidFill>
+            <a:srgbClr val="F4EEE8"/>
+          </a:solidFill>
+          <a:ln/>
+        </p:spPr>
+      </p:sp>
+      <p:sp>
+        <p:nvSpPr>
+          <p:cNvPr id="8" name="Shape 6"/>
+          <p:cNvSpPr/>
+          <p:nvPr/>
+        </p:nvSpPr>
+        <p:spPr>
+          <a:xfrm>
+            <a:off x="914400" y="3227832"/>
+            <a:ext cx="320040" cy="320040"/>
+          </a:xfrm>
+          <a:prstGeom prst="ellipse">
+            <a:avLst/>
+          </a:prstGeom>
+          <a:solidFill>
+            <a:srgbClr val="3F6F5F"/>
+          </a:solidFill>
+          <a:ln/>
+        </p:spPr>
+      </p:sp>
+      <p:sp>
+        <p:nvSpPr>
+          <p:cNvPr id="9" name="Text 7"/>
+          <p:cNvSpPr/>
+          <p:nvPr/>
+        </p:nvSpPr>
+        <p:spPr>
+          <a:xfrm>
+            <a:off x="1463040" y="3044952"/>
+            <a:ext cx="9784080" cy="850392"/>
+          </a:xfrm>
+          <a:prstGeom prst="rect">
+            <a:avLst/>
+          </a:prstGeom>
+          <a:noFill/>
+          <a:ln/>
+        </p:spPr>
+        <p:txBody>
+          <a:bodyPr wrap="square" lIns="0" tIns="0" rIns="0" bIns="0" rtlCol="0" anchor="ctr"/>
+          <a:lstStyle/>
+          <a:p>
+            <a:pPr indent="0" marL="0">
+              <a:buNone/>
+            </a:pPr>
+            <a:r>
+              <a:rPr lang="en-US" sz="1350" i="1" dirty="0">
+                <a:solidFill>
+                  <a:srgbClr val="1A1A1A"/>
+                </a:solidFill>
+                <a:latin typeface="Cambria" pitchFamily="34" charset="0"/>
+                <a:ea typeface="Cambria" pitchFamily="34" charset="-122"/>
+                <a:cs typeface="Cambria" pitchFamily="34" charset="-120"/>
+              </a:rPr>
+              <a:t>Two communities sit far apart in count-space. What exactly is far apart: the people, their topics, or the genre of writing? How would you tell?</a:t>
+            </a:r>
+            <a:endParaRPr lang="en-US" sz="1350" dirty="0"/>
+          </a:p>
+        </p:txBody>
+      </p:sp>
+      <p:sp>
+        <p:nvSpPr>
+          <p:cNvPr id="10" name="Shape 8"/>
+          <p:cNvSpPr/>
+          <p:nvPr/>
+        </p:nvSpPr>
+        <p:spPr>
+          <a:xfrm>
+            <a:off x="640080" y="4123944"/>
+            <a:ext cx="10881360" cy="987552"/>
+          </a:xfrm>
+          <a:prstGeom prst="roundRect">
+            <a:avLst>
+              <a:gd name="adj" fmla="val 9259"/>
+            </a:avLst>
+          </a:prstGeom>
+          <a:solidFill>
+            <a:srgbClr val="F4EEE8"/>
+          </a:solidFill>
+          <a:ln/>
+        </p:spPr>
+      </p:sp>
+      <p:sp>
+        <p:nvSpPr>
+          <p:cNvPr id="11" name="Shape 9"/>
+          <p:cNvSpPr/>
+          <p:nvPr/>
+        </p:nvSpPr>
+        <p:spPr>
+          <a:xfrm>
+            <a:off x="914400" y="4398264"/>
+            <a:ext cx="320040" cy="320040"/>
+          </a:xfrm>
+          <a:prstGeom prst="ellipse">
+            <a:avLst/>
+          </a:prstGeom>
+          <a:solidFill>
+            <a:srgbClr val="7A3B2E"/>
+          </a:solidFill>
+          <a:ln/>
+        </p:spPr>
+      </p:sp>
+      <p:sp>
+        <p:nvSpPr>
+          <p:cNvPr id="12" name="Text 10"/>
+          <p:cNvSpPr/>
+          <p:nvPr/>
+        </p:nvSpPr>
+        <p:spPr>
+          <a:xfrm>
+            <a:off x="1463040" y="4215384"/>
+            <a:ext cx="9784080" cy="850392"/>
+          </a:xfrm>
+          <a:prstGeom prst="rect">
+            <a:avLst/>
+          </a:prstGeom>
+          <a:noFill/>
+          <a:ln/>
+        </p:spPr>
+        <p:txBody>
+          <a:bodyPr wrap="square" lIns="0" tIns="0" rIns="0" bIns="0" rtlCol="0" anchor="ctr"/>
+          <a:lstStyle/>
+          <a:p>
+            <a:pPr indent="0" marL="0">
+              <a:buNone/>
+            </a:pPr>
+            <a:r>
+              <a:rPr lang="en-US" sz="1350" i="1" dirty="0">
+                <a:solidFill>
+                  <a:srgbClr val="1A1A1A"/>
+                </a:solidFill>
+                <a:latin typeface="Cambria" pitchFamily="34" charset="0"/>
+                <a:ea typeface="Cambria" pitchFamily="34" charset="-122"/>
+                <a:cs typeface="Cambria" pitchFamily="34" charset="-120"/>
+              </a:rPr>
+              <a:t>Your trend beat shuffled years. Is the finding TRUE? What separates “not chance” from “what I said it means”?</a:t>
+            </a:r>
+            <a:endParaRPr lang="en-US" sz="1350" dirty="0"/>
+          </a:p>
+        </p:txBody>
+      </p:sp>
+      <p:sp>
+        <p:nvSpPr>
+          <p:cNvPr id="13" name="Shape 11"/>
+          <p:cNvSpPr/>
+          <p:nvPr/>
+        </p:nvSpPr>
+        <p:spPr>
+          <a:xfrm>
+            <a:off x="640080" y="5294376"/>
+            <a:ext cx="10881360" cy="987552"/>
+          </a:xfrm>
+          <a:prstGeom prst="roundRect">
+            <a:avLst>
+              <a:gd name="adj" fmla="val 9259"/>
+            </a:avLst>
+          </a:prstGeom>
+          <a:solidFill>
+            <a:srgbClr val="F4EEE8"/>
+          </a:solidFill>
+          <a:ln/>
+        </p:spPr>
+      </p:sp>
+      <p:sp>
+        <p:nvSpPr>
+          <p:cNvPr id="14" name="Shape 12"/>
+          <p:cNvSpPr/>
+          <p:nvPr/>
+        </p:nvSpPr>
+        <p:spPr>
+          <a:xfrm>
+            <a:off x="914400" y="5568696"/>
+            <a:ext cx="320040" cy="320040"/>
+          </a:xfrm>
+          <a:prstGeom prst="ellipse">
+            <a:avLst/>
+          </a:prstGeom>
+          <a:solidFill>
+            <a:srgbClr val="B9852F"/>
+          </a:solidFill>
+          <a:ln/>
+        </p:spPr>
+      </p:sp>
+      <p:sp>
+        <p:nvSpPr>
+          <p:cNvPr id="15" name="Text 13"/>
+          <p:cNvSpPr/>
+          <p:nvPr/>
+        </p:nvSpPr>
+        <p:spPr>
+          <a:xfrm>
+            <a:off x="1463040" y="5385816"/>
+            <a:ext cx="9784080" cy="850392"/>
+          </a:xfrm>
+          <a:prstGeom prst="rect">
+            <a:avLst/>
+          </a:prstGeom>
+          <a:noFill/>
+          <a:ln/>
+        </p:spPr>
+        <p:txBody>
+          <a:bodyPr wrap="square" lIns="0" tIns="0" rIns="0" bIns="0" rtlCol="0" anchor="ctr"/>
+          <a:lstStyle/>
+          <a:p>
+            <a:pPr indent="0" marL="0">
+              <a:buNone/>
+            </a:pPr>
+            <a:r>
+              <a:rPr lang="en-US" sz="1350" i="1" dirty="0">
+                <a:solidFill>
+                  <a:srgbClr val="1A1A1A"/>
+                </a:solidFill>
+                <a:latin typeface="Cambria" pitchFamily="34" charset="0"/>
+                <a:ea typeface="Cambria" pitchFamily="34" charset="-122"/>
+                <a:cs typeface="Cambria" pitchFamily="34" charset="-120"/>
+              </a:rPr>
+              <a:t>The ratio climbed in books AND on Reddit. One truth measured twice, or two facts about two archives? What third corpus would decide?</a:t>
+            </a:r>
+            <a:endParaRPr lang="en-US" sz="1350" dirty="0"/>
+          </a:p>
+        </p:txBody>
+      </p:sp>
+    </p:spTree>
+  </p:cSld>
+  <p:clrMapOvr>
+    <a:masterClrMapping/>
+  </p:clrMapOvr>
+</p:sld>
+</file>
+
+<file path=ppt/slides/slide19.xml><?xml version="1.0" encoding="utf-8"?>
+<p:sld xmlns:a="http://schemas.openxmlformats.org/drawingml/2006/main" xmlns:r="http://schemas.openxmlformats.org/officeDocument/2006/relationships" xmlns:p="http://schemas.openxmlformats.org/presentationml/2006/main">
+  <p:cSld name="Slide 19">
     <p:bg>
       <p:bgPr>
         <a:solidFill>
@@ -6181,7 +7355,7 @@
                 <a:ea typeface="Calibri" pitchFamily="34" charset="-122"/>
                 <a:cs typeface="Calibri" pitchFamily="34" charset="-120"/>
               </a:rPr>
-              <a:t>z-scores and the shuffle test, hands on</a:t>
+              <a:t>z-scores, the shuffle test, the bootstrap: hands on</a:t>
             </a:r>
             <a:endParaRPr lang="en-US" sz="1250" dirty="0"/>
           </a:p>
@@ -6624,11 +7798,11 @@
         <p:spPr>
           <a:xfrm>
             <a:off x="640080" y="2011680"/>
-            <a:ext cx="10881360" cy="1143000"/>
+            <a:ext cx="10881360" cy="1188720"/>
           </a:xfrm>
           <a:prstGeom prst="roundRect">
             <a:avLst>
-              <a:gd name="adj" fmla="val 8000"/>
+              <a:gd name="adj" fmla="val 7692"/>
             </a:avLst>
           </a:prstGeom>
           <a:solidFill>
@@ -6665,8 +7839,8 @@
         </p:nvSpPr>
         <p:spPr>
           <a:xfrm>
-            <a:off x="1463040" y="2121408"/>
-            <a:ext cx="9784080" cy="914400"/>
+            <a:off x="1463040" y="2103120"/>
+            <a:ext cx="9784080" cy="1051560"/>
           </a:xfrm>
           <a:prstGeom prst="rect">
             <a:avLst/>
@@ -6682,7 +7856,7 @@
               <a:buNone/>
             </a:pPr>
             <a:r>
-              <a:rPr lang="en-US" sz="1600" i="1" dirty="0">
+              <a:rPr lang="en-US" sz="1500" i="1" dirty="0">
                 <a:solidFill>
                   <a:srgbClr val="1A1A1A"/>
                 </a:solidFill>
@@ -6690,9 +7864,9 @@
                 <a:ea typeface="Cambria" pitchFamily="34" charset="-122"/>
                 <a:cs typeface="Cambria" pitchFamily="34" charset="-120"/>
               </a:rPr>
-              <a:t>“I am a failure” appears in a book. What are the possible reasons, and how many of them are distress?</a:t>
-            </a:r>
-            <a:endParaRPr lang="en-US" sz="1600" dirty="0"/>
+              <a:t>“I am a failure” appears in a book. List the possible reasons it was written. How many of them are distress?</a:t>
+            </a:r>
+            <a:endParaRPr lang="en-US" sz="1500" dirty="0"/>
           </a:p>
         </p:txBody>
       </p:sp>
@@ -6705,11 +7879,11 @@
         <p:spPr>
           <a:xfrm>
             <a:off x="640080" y="3383280"/>
-            <a:ext cx="10881360" cy="1143000"/>
+            <a:ext cx="10881360" cy="1188720"/>
           </a:xfrm>
           <a:prstGeom prst="roundRect">
             <a:avLst>
-              <a:gd name="adj" fmla="val 8000"/>
+              <a:gd name="adj" fmla="val 7692"/>
             </a:avLst>
           </a:prstGeom>
           <a:solidFill>
@@ -6746,8 +7920,8 @@
         </p:nvSpPr>
         <p:spPr>
           <a:xfrm>
-            <a:off x="1463040" y="3493008"/>
-            <a:ext cx="9784080" cy="914400"/>
+            <a:off x="1463040" y="3474720"/>
+            <a:ext cx="9784080" cy="1051560"/>
           </a:xfrm>
           <a:prstGeom prst="rect">
             <a:avLst/>
@@ -6763,7 +7937,7 @@
               <a:buNone/>
             </a:pPr>
             <a:r>
-              <a:rPr lang="en-US" sz="1600" i="1" dirty="0">
+              <a:rPr lang="en-US" sz="1500" i="1" dirty="0">
                 <a:solidFill>
                   <a:srgbClr val="1A1A1A"/>
                 </a:solidFill>
@@ -6773,7 +7947,7 @@
               </a:rPr>
               <a:t>If a phrase's frequency doubles, what claims does that support: about authors? readers? publishers? the age?</a:t>
             </a:r>
-            <a:endParaRPr lang="en-US" sz="1600" dirty="0"/>
+            <a:endParaRPr lang="en-US" sz="1500" dirty="0"/>
           </a:p>
         </p:txBody>
       </p:sp>
@@ -6786,11 +7960,11 @@
         <p:spPr>
           <a:xfrm>
             <a:off x="640080" y="4754880"/>
-            <a:ext cx="10881360" cy="1143000"/>
+            <a:ext cx="10881360" cy="1188720"/>
           </a:xfrm>
           <a:prstGeom prst="roundRect">
             <a:avLst>
-              <a:gd name="adj" fmla="val 8000"/>
+              <a:gd name="adj" fmla="val 7692"/>
             </a:avLst>
           </a:prstGeom>
           <a:solidFill>
@@ -6827,8 +8001,8 @@
         </p:nvSpPr>
         <p:spPr>
           <a:xfrm>
-            <a:off x="1463040" y="4864608"/>
-            <a:ext cx="9784080" cy="914400"/>
+            <a:off x="1463040" y="4846320"/>
+            <a:ext cx="9784080" cy="1051560"/>
           </a:xfrm>
           <a:prstGeom prst="rect">
             <a:avLst/>
@@ -6844,7 +8018,7 @@
               <a:buNone/>
             </a:pPr>
             <a:r>
-              <a:rPr lang="en-US" sz="1600" i="1" dirty="0">
+              <a:rPr lang="en-US" sz="1500" i="1" dirty="0">
                 <a:solidFill>
                   <a:srgbClr val="1A1A1A"/>
                 </a:solidFill>
@@ -6854,7 +8028,7 @@
               </a:rPr>
               <a:t>What would you accept as evidence that a society got sadder? Write it down; today tests your standard.</a:t>
             </a:r>
-            <a:endParaRPr lang="en-US" sz="1600" dirty="0"/>
+            <a:endParaRPr lang="en-US" sz="1500" dirty="0"/>
           </a:p>
         </p:txBody>
       </p:sp>

</xml_diff>